<commit_message>
Enhance PPT with longer content and original images
Co-authored-by: rpraut2008-stack <246952107+rpraut2008-stack@users.noreply.github.com>
</commit_message>
<xml_diff>
--- a/Effects_of_Urea_on_Plant_Growth.pptx
+++ b/Effects_of_Urea_on_Plant_Growth.pptx
@@ -3125,9 +3125,9 @@
             <a:avLst/>
           </a:prstGeom>
           <a:noFill/>
-          <a:ln w="27940">
+          <a:ln w="31750">
             <a:solidFill>
-              <a:srgbClr val="1F5F3A"/>
+              <a:srgbClr val="1D5C38"/>
             </a:solidFill>
           </a:ln>
         </p:spPr>
@@ -3161,18 +3161,18 @@
         </p:nvSpPr>
         <p:spPr>
           <a:xfrm>
-            <a:off x="438912" y="411480"/>
-            <a:ext cx="5980176" cy="914400"/>
+            <a:off x="411480" y="384048"/>
+            <a:ext cx="6035040" cy="960120"/>
           </a:xfrm>
           <a:prstGeom prst="roundRect">
             <a:avLst/>
           </a:prstGeom>
           <a:solidFill>
-            <a:srgbClr val="397B47"/>
+            <a:srgbClr val="2A7E49"/>
           </a:solidFill>
           <a:ln>
             <a:solidFill>
-              <a:srgbClr val="397B47"/>
+              <a:srgbClr val="2A7E49"/>
             </a:solidFill>
           </a:ln>
         </p:spPr>
@@ -3214,8 +3214,8 @@
         </p:nvSpPr>
         <p:spPr>
           <a:xfrm>
-            <a:off x="530352" y="1600200"/>
-            <a:ext cx="5797296" cy="6629400"/>
+            <a:off x="502920" y="1572768"/>
+            <a:ext cx="5806440" cy="6355080"/>
           </a:xfrm>
           <a:prstGeom prst="rect">
             <a:avLst/>
@@ -3229,74 +3229,84 @@
           <a:lstStyle/>
           <a:p>
             <a:pPr algn="l">
+              <a:lnSpc>
+                <a:spcPct val="115000"/>
+              </a:lnSpc>
               <a:spcAft>
                 <a:spcPts val="1000"/>
               </a:spcAft>
             </a:pPr>
             <a:r>
-              <a:rPr sz="1800">
-                <a:solidFill>
-                  <a:srgbClr val="1D1D1D"/>
-                </a:solidFill>
-              </a:rPr>
-              <a:t>A student project on how urea influences germination, plant health, and sustainable agricultural outcomes.</a:t>
-            </a:r>
-          </a:p>
-        </p:txBody>
-      </p:sp>
-      <p:sp>
-        <p:nvSpPr>
-          <p:cNvPr id="5" name="Rectangle 4"/>
-          <p:cNvSpPr/>
-          <p:nvPr/>
-        </p:nvSpPr>
-        <p:spPr>
-          <a:xfrm>
-            <a:off x="530352" y="8732520"/>
-            <a:ext cx="5797296" cy="2697480"/>
+              <a:rPr sz="1700">
+                <a:solidFill>
+                  <a:srgbClr val="1E1E1E"/>
+                </a:solidFill>
+              </a:rPr>
+              <a:t>• This presentation explains how urea fertilizer influences seed germination, vegetative growth, and final plant health under controlled conditions.</a:t>
+            </a:r>
+          </a:p>
+          <a:p>
+            <a:pPr algn="l">
+              <a:lnSpc>
+                <a:spcPct val="115000"/>
+              </a:lnSpc>
+              <a:spcAft>
+                <a:spcPts val="1000"/>
+              </a:spcAft>
+            </a:pPr>
+            <a:r>
+              <a:rPr sz="1700">
+                <a:solidFill>
+                  <a:srgbClr val="1E1E1E"/>
+                </a:solidFill>
+              </a:rPr>
+              <a:t>• It also compares the positive effects of balanced application with the risks caused by excess chemical fertilizer in soil and water systems.</a:t>
+            </a:r>
+          </a:p>
+          <a:p>
+            <a:pPr algn="l">
+              <a:lnSpc>
+                <a:spcPct val="115000"/>
+              </a:lnSpc>
+              <a:spcAft>
+                <a:spcPts val="1000"/>
+              </a:spcAft>
+            </a:pPr>
+            <a:r>
+              <a:rPr sz="1700">
+                <a:solidFill>
+                  <a:srgbClr val="1E1E1E"/>
+                </a:solidFill>
+              </a:rPr>
+              <a:t>• The project is designed as a school-ready scientific study with clear observations, inference, and conclusion.</a:t>
+            </a:r>
+          </a:p>
+        </p:txBody>
+      </p:sp>
+      <p:pic>
+        <p:nvPicPr>
+          <p:cNvPr id="5" name="Picture 4" descr="slide_01.png"/>
+          <p:cNvPicPr>
+            <a:picLocks noChangeAspect="1"/>
+          </p:cNvPicPr>
+          <p:nvPr/>
+        </p:nvPicPr>
+        <p:blipFill>
+          <a:blip r:embed="rId2"/>
+          <a:stretch>
+            <a:fillRect/>
+          </a:stretch>
+        </p:blipFill>
+        <p:spPr>
+          <a:xfrm>
+            <a:off x="502920" y="8183879"/>
+            <a:ext cx="5806440" cy="3063240"/>
           </a:xfrm>
           <a:prstGeom prst="rect">
             <a:avLst/>
           </a:prstGeom>
-          <a:solidFill>
-            <a:srgbClr val="F3F9F4"/>
-          </a:solidFill>
-          <a:ln w="22860">
-            <a:solidFill>
-              <a:srgbClr val="4E8C5B"/>
-            </a:solidFill>
-          </a:ln>
-        </p:spPr>
-        <p:style>
-          <a:lnRef idx="1">
-            <a:schemeClr val="accent1"/>
-          </a:lnRef>
-          <a:fillRef idx="3">
-            <a:schemeClr val="accent1"/>
-          </a:fillRef>
-          <a:effectRef idx="2">
-            <a:schemeClr val="accent1"/>
-          </a:effectRef>
-          <a:fontRef idx="minor">
-            <a:schemeClr val="lt1"/>
-          </a:fontRef>
-        </p:style>
-        <p:txBody>
-          <a:bodyPr rtlCol="0" anchor="ctr"/>
-          <a:lstStyle/>
-          <a:p>
-            <a:pPr algn="ctr"/>
-            <a:r>
-              <a:rPr b="1" sz="1600">
-                <a:solidFill>
-                  <a:srgbClr val="376D41"/>
-                </a:solidFill>
-              </a:rPr>
-              <a:t>Image Placeholder: Healthy crop field with fertilizer application</a:t>
-            </a:r>
-          </a:p>
-        </p:txBody>
-      </p:sp>
+        </p:spPr>
+      </p:pic>
     </p:spTree>
   </p:cSld>
   <p:clrMapOvr>
@@ -3330,9 +3340,9 @@
             <a:avLst/>
           </a:prstGeom>
           <a:noFill/>
-          <a:ln w="27940">
+          <a:ln w="31750">
             <a:solidFill>
-              <a:srgbClr val="1F5F3A"/>
+              <a:srgbClr val="1D5C38"/>
             </a:solidFill>
           </a:ln>
         </p:spPr>
@@ -3366,18 +3376,18 @@
         </p:nvSpPr>
         <p:spPr>
           <a:xfrm>
-            <a:off x="438912" y="411480"/>
-            <a:ext cx="5980176" cy="914400"/>
+            <a:off x="411480" y="384048"/>
+            <a:ext cx="6035040" cy="960120"/>
           </a:xfrm>
           <a:prstGeom prst="roundRect">
             <a:avLst/>
           </a:prstGeom>
           <a:solidFill>
-            <a:srgbClr val="397B47"/>
+            <a:srgbClr val="2A7E49"/>
           </a:solidFill>
           <a:ln>
             <a:solidFill>
-              <a:srgbClr val="397B47"/>
+              <a:srgbClr val="2A7E49"/>
             </a:solidFill>
           </a:ln>
         </p:spPr>
@@ -3419,8 +3429,8 @@
         </p:nvSpPr>
         <p:spPr>
           <a:xfrm>
-            <a:off x="530352" y="1600200"/>
-            <a:ext cx="5797296" cy="6629400"/>
+            <a:off x="502920" y="1572768"/>
+            <a:ext cx="5806440" cy="6355080"/>
           </a:xfrm>
           <a:prstGeom prst="rect">
             <a:avLst/>
@@ -3434,89 +3444,84 @@
           <a:lstStyle/>
           <a:p>
             <a:pPr algn="l">
+              <a:lnSpc>
+                <a:spcPct val="115000"/>
+              </a:lnSpc>
               <a:spcAft>
                 <a:spcPts val="1000"/>
               </a:spcAft>
             </a:pPr>
             <a:r>
-              <a:rPr sz="1800">
-                <a:solidFill>
-                  <a:srgbClr val="1D1D1D"/>
-                </a:solidFill>
-              </a:rPr>
-              <a:t>• Temperature regulates enzyme activity and metabolic speed during germination.</a:t>
+              <a:rPr sz="1700">
+                <a:solidFill>
+                  <a:srgbClr val="1E1E1E"/>
+                </a:solidFill>
+              </a:rPr>
+              <a:t>• Temperature controls metabolic rate and enzyme efficiency, making it a major factor in how quickly seeds germinate.</a:t>
             </a:r>
           </a:p>
           <a:p>
             <a:pPr algn="l">
+              <a:lnSpc>
+                <a:spcPct val="115000"/>
+              </a:lnSpc>
               <a:spcAft>
                 <a:spcPts val="1000"/>
               </a:spcAft>
             </a:pPr>
             <a:r>
-              <a:rPr sz="1800">
-                <a:solidFill>
-                  <a:srgbClr val="1D1D1D"/>
-                </a:solidFill>
-              </a:rPr>
-              <a:t>• Every species has an optimum temperature range, and extremes can inhibit germination.</a:t>
-            </a:r>
-          </a:p>
-        </p:txBody>
-      </p:sp>
-      <p:sp>
-        <p:nvSpPr>
-          <p:cNvPr id="5" name="Rectangle 4"/>
-          <p:cNvSpPr/>
-          <p:nvPr/>
-        </p:nvSpPr>
-        <p:spPr>
-          <a:xfrm>
-            <a:off x="530352" y="8732520"/>
-            <a:ext cx="5797296" cy="2697480"/>
+              <a:rPr sz="1700">
+                <a:solidFill>
+                  <a:srgbClr val="1E1E1E"/>
+                </a:solidFill>
+              </a:rPr>
+              <a:t>• Each crop has a minimum, optimum, and maximum germination temperature range that must be respected for best results.</a:t>
+            </a:r>
+          </a:p>
+          <a:p>
+            <a:pPr algn="l">
+              <a:lnSpc>
+                <a:spcPct val="115000"/>
+              </a:lnSpc>
+              <a:spcAft>
+                <a:spcPts val="1000"/>
+              </a:spcAft>
+            </a:pPr>
+            <a:r>
+              <a:rPr sz="1700">
+                <a:solidFill>
+                  <a:srgbClr val="1E1E1E"/>
+                </a:solidFill>
+              </a:rPr>
+              <a:t>• Extreme temperatures may denature enzymes or slow metabolism, resulting in poor and uneven germination.</a:t>
+            </a:r>
+          </a:p>
+        </p:txBody>
+      </p:sp>
+      <p:pic>
+        <p:nvPicPr>
+          <p:cNvPr id="5" name="Picture 4" descr="slide_10.png"/>
+          <p:cNvPicPr>
+            <a:picLocks noChangeAspect="1"/>
+          </p:cNvPicPr>
+          <p:nvPr/>
+        </p:nvPicPr>
+        <p:blipFill>
+          <a:blip r:embed="rId2"/>
+          <a:stretch>
+            <a:fillRect/>
+          </a:stretch>
+        </p:blipFill>
+        <p:spPr>
+          <a:xfrm>
+            <a:off x="502920" y="8183879"/>
+            <a:ext cx="5806440" cy="3063240"/>
           </a:xfrm>
           <a:prstGeom prst="rect">
             <a:avLst/>
           </a:prstGeom>
-          <a:solidFill>
-            <a:srgbClr val="F3F9F4"/>
-          </a:solidFill>
-          <a:ln w="22860">
-            <a:solidFill>
-              <a:srgbClr val="4E8C5B"/>
-            </a:solidFill>
-          </a:ln>
-        </p:spPr>
-        <p:style>
-          <a:lnRef idx="1">
-            <a:schemeClr val="accent1"/>
-          </a:lnRef>
-          <a:fillRef idx="3">
-            <a:schemeClr val="accent1"/>
-          </a:fillRef>
-          <a:effectRef idx="2">
-            <a:schemeClr val="accent1"/>
-          </a:effectRef>
-          <a:fontRef idx="minor">
-            <a:schemeClr val="lt1"/>
-          </a:fontRef>
-        </p:style>
-        <p:txBody>
-          <a:bodyPr rtlCol="0" anchor="ctr"/>
-          <a:lstStyle/>
-          <a:p>
-            <a:pPr algn="ctr"/>
-            <a:r>
-              <a:rPr b="1" sz="1600">
-                <a:solidFill>
-                  <a:srgbClr val="376D41"/>
-                </a:solidFill>
-              </a:rPr>
-              <a:t>Image Placeholder: Thermometer with seedlings</a:t>
-            </a:r>
-          </a:p>
-        </p:txBody>
-      </p:sp>
+        </p:spPr>
+      </p:pic>
     </p:spTree>
   </p:cSld>
   <p:clrMapOvr>
@@ -3550,9 +3555,9 @@
             <a:avLst/>
           </a:prstGeom>
           <a:noFill/>
-          <a:ln w="27940">
+          <a:ln w="31750">
             <a:solidFill>
-              <a:srgbClr val="1F5F3A"/>
+              <a:srgbClr val="1D5C38"/>
             </a:solidFill>
           </a:ln>
         </p:spPr>
@@ -3586,18 +3591,18 @@
         </p:nvSpPr>
         <p:spPr>
           <a:xfrm>
-            <a:off x="438912" y="411480"/>
-            <a:ext cx="5980176" cy="914400"/>
+            <a:off x="411480" y="384048"/>
+            <a:ext cx="6035040" cy="960120"/>
           </a:xfrm>
           <a:prstGeom prst="roundRect">
             <a:avLst/>
           </a:prstGeom>
           <a:solidFill>
-            <a:srgbClr val="397B47"/>
+            <a:srgbClr val="2A7E49"/>
           </a:solidFill>
           <a:ln>
             <a:solidFill>
-              <a:srgbClr val="397B47"/>
+              <a:srgbClr val="2A7E49"/>
             </a:solidFill>
           </a:ln>
         </p:spPr>
@@ -3639,8 +3644,8 @@
         </p:nvSpPr>
         <p:spPr>
           <a:xfrm>
-            <a:off x="530352" y="1600200"/>
-            <a:ext cx="5797296" cy="6629400"/>
+            <a:off x="502920" y="1572768"/>
+            <a:ext cx="5806440" cy="6355080"/>
           </a:xfrm>
           <a:prstGeom prst="rect">
             <a:avLst/>
@@ -3654,89 +3659,84 @@
           <a:lstStyle/>
           <a:p>
             <a:pPr algn="l">
+              <a:lnSpc>
+                <a:spcPct val="115000"/>
+              </a:lnSpc>
               <a:spcAft>
                 <a:spcPts val="1000"/>
               </a:spcAft>
             </a:pPr>
             <a:r>
-              <a:rPr sz="1800">
-                <a:solidFill>
-                  <a:srgbClr val="1D1D1D"/>
-                </a:solidFill>
-              </a:rPr>
-              <a:t>• Some seeds germinate better in light, while others germinate better in darkness.</a:t>
+              <a:rPr sz="1700">
+                <a:solidFill>
+                  <a:srgbClr val="1E1E1E"/>
+                </a:solidFill>
+              </a:rPr>
+              <a:t>• Certain seeds are light-sensitive and may require either light exposure or darkness to trigger germination mechanisms.</a:t>
             </a:r>
           </a:p>
           <a:p>
             <a:pPr algn="l">
+              <a:lnSpc>
+                <a:spcPct val="115000"/>
+              </a:lnSpc>
               <a:spcAft>
                 <a:spcPts val="1000"/>
               </a:spcAft>
             </a:pPr>
             <a:r>
-              <a:rPr sz="1800">
-                <a:solidFill>
-                  <a:srgbClr val="1D1D1D"/>
-                </a:solidFill>
-              </a:rPr>
-              <a:t>• Light also influences early seedling development after sprouting.</a:t>
-            </a:r>
-          </a:p>
-        </p:txBody>
-      </p:sp>
-      <p:sp>
-        <p:nvSpPr>
-          <p:cNvPr id="5" name="Rectangle 4"/>
-          <p:cNvSpPr/>
-          <p:nvPr/>
-        </p:nvSpPr>
-        <p:spPr>
-          <a:xfrm>
-            <a:off x="530352" y="8732520"/>
-            <a:ext cx="5797296" cy="2697480"/>
+              <a:rPr sz="1700">
+                <a:solidFill>
+                  <a:srgbClr val="1E1E1E"/>
+                </a:solidFill>
+              </a:rPr>
+              <a:t>• After sprouting, adequate light intensity is crucial for chlorophyll development and sturdy shoot growth.</a:t>
+            </a:r>
+          </a:p>
+          <a:p>
+            <a:pPr algn="l">
+              <a:lnSpc>
+                <a:spcPct val="115000"/>
+              </a:lnSpc>
+              <a:spcAft>
+                <a:spcPts val="1000"/>
+              </a:spcAft>
+            </a:pPr>
+            <a:r>
+              <a:rPr sz="1700">
+                <a:solidFill>
+                  <a:srgbClr val="1E1E1E"/>
+                </a:solidFill>
+              </a:rPr>
+              <a:t>• Poor light management can produce weak, elongated seedlings with low survival potential.</a:t>
+            </a:r>
+          </a:p>
+        </p:txBody>
+      </p:sp>
+      <p:pic>
+        <p:nvPicPr>
+          <p:cNvPr id="5" name="Picture 4" descr="slide_11.png"/>
+          <p:cNvPicPr>
+            <a:picLocks noChangeAspect="1"/>
+          </p:cNvPicPr>
+          <p:nvPr/>
+        </p:nvPicPr>
+        <p:blipFill>
+          <a:blip r:embed="rId2"/>
+          <a:stretch>
+            <a:fillRect/>
+          </a:stretch>
+        </p:blipFill>
+        <p:spPr>
+          <a:xfrm>
+            <a:off x="502920" y="8183879"/>
+            <a:ext cx="5806440" cy="3063240"/>
           </a:xfrm>
           <a:prstGeom prst="rect">
             <a:avLst/>
           </a:prstGeom>
-          <a:solidFill>
-            <a:srgbClr val="F3F9F4"/>
-          </a:solidFill>
-          <a:ln w="22860">
-            <a:solidFill>
-              <a:srgbClr val="4E8C5B"/>
-            </a:solidFill>
-          </a:ln>
-        </p:spPr>
-        <p:style>
-          <a:lnRef idx="1">
-            <a:schemeClr val="accent1"/>
-          </a:lnRef>
-          <a:fillRef idx="3">
-            <a:schemeClr val="accent1"/>
-          </a:fillRef>
-          <a:effectRef idx="2">
-            <a:schemeClr val="accent1"/>
-          </a:effectRef>
-          <a:fontRef idx="minor">
-            <a:schemeClr val="lt1"/>
-          </a:fontRef>
-        </p:style>
-        <p:txBody>
-          <a:bodyPr rtlCol="0" anchor="ctr"/>
-          <a:lstStyle/>
-          <a:p>
-            <a:pPr algn="ctr"/>
-            <a:r>
-              <a:rPr b="1" sz="1600">
-                <a:solidFill>
-                  <a:srgbClr val="376D41"/>
-                </a:solidFill>
-              </a:rPr>
-              <a:t>Image Placeholder: Light vs shade germination setup</a:t>
-            </a:r>
-          </a:p>
-        </p:txBody>
-      </p:sp>
+        </p:spPr>
+      </p:pic>
     </p:spTree>
   </p:cSld>
   <p:clrMapOvr>
@@ -3770,9 +3770,9 @@
             <a:avLst/>
           </a:prstGeom>
           <a:noFill/>
-          <a:ln w="27940">
+          <a:ln w="31750">
             <a:solidFill>
-              <a:srgbClr val="1F5F3A"/>
+              <a:srgbClr val="1D5C38"/>
             </a:solidFill>
           </a:ln>
         </p:spPr>
@@ -3806,18 +3806,18 @@
         </p:nvSpPr>
         <p:spPr>
           <a:xfrm>
-            <a:off x="438912" y="411480"/>
-            <a:ext cx="5980176" cy="914400"/>
+            <a:off x="411480" y="384048"/>
+            <a:ext cx="6035040" cy="960120"/>
           </a:xfrm>
           <a:prstGeom prst="roundRect">
             <a:avLst/>
           </a:prstGeom>
           <a:solidFill>
-            <a:srgbClr val="397B47"/>
+            <a:srgbClr val="2A7E49"/>
           </a:solidFill>
           <a:ln>
             <a:solidFill>
-              <a:srgbClr val="397B47"/>
+              <a:srgbClr val="2A7E49"/>
             </a:solidFill>
           </a:ln>
         </p:spPr>
@@ -3859,8 +3859,8 @@
         </p:nvSpPr>
         <p:spPr>
           <a:xfrm>
-            <a:off x="530352" y="1600200"/>
-            <a:ext cx="5797296" cy="6629400"/>
+            <a:off x="502920" y="1572768"/>
+            <a:ext cx="5806440" cy="6355080"/>
           </a:xfrm>
           <a:prstGeom prst="rect">
             <a:avLst/>
@@ -3874,89 +3874,84 @@
           <a:lstStyle/>
           <a:p>
             <a:pPr algn="l">
+              <a:lnSpc>
+                <a:spcPct val="115000"/>
+              </a:lnSpc>
               <a:spcAft>
                 <a:spcPts val="1000"/>
               </a:spcAft>
             </a:pPr>
             <a:r>
-              <a:rPr sz="1800">
-                <a:solidFill>
-                  <a:srgbClr val="1D1D1D"/>
-                </a:solidFill>
-              </a:rPr>
-              <a:t>• Internal factors are properties of the seed itself that determine its readiness to germinate.</a:t>
+              <a:rPr sz="1700">
+                <a:solidFill>
+                  <a:srgbClr val="1E1E1E"/>
+                </a:solidFill>
+              </a:rPr>
+              <a:t>• Internal factors refer to biological properties of seeds that determine whether they can germinate under favorable conditions.</a:t>
             </a:r>
           </a:p>
           <a:p>
             <a:pPr algn="l">
+              <a:lnSpc>
+                <a:spcPct val="115000"/>
+              </a:lnSpc>
               <a:spcAft>
                 <a:spcPts val="1000"/>
               </a:spcAft>
             </a:pPr>
             <a:r>
-              <a:rPr sz="1800">
-                <a:solidFill>
-                  <a:srgbClr val="1D1D1D"/>
-                </a:solidFill>
-              </a:rPr>
-              <a:t>• These include vitality, longevity or viability, and dormancy mechanisms.</a:t>
-            </a:r>
-          </a:p>
-        </p:txBody>
-      </p:sp>
-      <p:sp>
-        <p:nvSpPr>
-          <p:cNvPr id="5" name="Rectangle 4"/>
-          <p:cNvSpPr/>
-          <p:nvPr/>
-        </p:nvSpPr>
-        <p:spPr>
-          <a:xfrm>
-            <a:off x="530352" y="8732520"/>
-            <a:ext cx="5797296" cy="2697480"/>
+              <a:rPr sz="1700">
+                <a:solidFill>
+                  <a:srgbClr val="1E1E1E"/>
+                </a:solidFill>
+              </a:rPr>
+              <a:t>• Vitality influences seedling strength, viability represents lifespan of germination potential, and dormancy controls timing.</a:t>
+            </a:r>
+          </a:p>
+          <a:p>
+            <a:pPr algn="l">
+              <a:lnSpc>
+                <a:spcPct val="115000"/>
+              </a:lnSpc>
+              <a:spcAft>
+                <a:spcPts val="1000"/>
+              </a:spcAft>
+            </a:pPr>
+            <a:r>
+              <a:rPr sz="1700">
+                <a:solidFill>
+                  <a:srgbClr val="1E1E1E"/>
+                </a:solidFill>
+              </a:rPr>
+              <a:t>• These factors explain why two seed batches can perform differently under identical external conditions.</a:t>
+            </a:r>
+          </a:p>
+        </p:txBody>
+      </p:sp>
+      <p:pic>
+        <p:nvPicPr>
+          <p:cNvPr id="5" name="Picture 4" descr="slide_12.png"/>
+          <p:cNvPicPr>
+            <a:picLocks noChangeAspect="1"/>
+          </p:cNvPicPr>
+          <p:nvPr/>
+        </p:nvPicPr>
+        <p:blipFill>
+          <a:blip r:embed="rId2"/>
+          <a:stretch>
+            <a:fillRect/>
+          </a:stretch>
+        </p:blipFill>
+        <p:spPr>
+          <a:xfrm>
+            <a:off x="502920" y="8183879"/>
+            <a:ext cx="5806440" cy="3063240"/>
           </a:xfrm>
           <a:prstGeom prst="rect">
             <a:avLst/>
           </a:prstGeom>
-          <a:solidFill>
-            <a:srgbClr val="F3F9F4"/>
-          </a:solidFill>
-          <a:ln w="22860">
-            <a:solidFill>
-              <a:srgbClr val="4E8C5B"/>
-            </a:solidFill>
-          </a:ln>
-        </p:spPr>
-        <p:style>
-          <a:lnRef idx="1">
-            <a:schemeClr val="accent1"/>
-          </a:lnRef>
-          <a:fillRef idx="3">
-            <a:schemeClr val="accent1"/>
-          </a:fillRef>
-          <a:effectRef idx="2">
-            <a:schemeClr val="accent1"/>
-          </a:effectRef>
-          <a:fontRef idx="minor">
-            <a:schemeClr val="lt1"/>
-          </a:fontRef>
-        </p:style>
-        <p:txBody>
-          <a:bodyPr rtlCol="0" anchor="ctr"/>
-          <a:lstStyle/>
-          <a:p>
-            <a:pPr algn="ctr"/>
-            <a:r>
-              <a:rPr b="1" sz="1600">
-                <a:solidFill>
-                  <a:srgbClr val="376D41"/>
-                </a:solidFill>
-              </a:rPr>
-              <a:t>Image Placeholder: Seed anatomy cross-section</a:t>
-            </a:r>
-          </a:p>
-        </p:txBody>
-      </p:sp>
+        </p:spPr>
+      </p:pic>
     </p:spTree>
   </p:cSld>
   <p:clrMapOvr>
@@ -3990,9 +3985,9 @@
             <a:avLst/>
           </a:prstGeom>
           <a:noFill/>
-          <a:ln w="27940">
+          <a:ln w="31750">
             <a:solidFill>
-              <a:srgbClr val="1F5F3A"/>
+              <a:srgbClr val="1D5C38"/>
             </a:solidFill>
           </a:ln>
         </p:spPr>
@@ -4026,18 +4021,18 @@
         </p:nvSpPr>
         <p:spPr>
           <a:xfrm>
-            <a:off x="438912" y="411480"/>
-            <a:ext cx="5980176" cy="914400"/>
+            <a:off x="411480" y="384048"/>
+            <a:ext cx="6035040" cy="960120"/>
           </a:xfrm>
           <a:prstGeom prst="roundRect">
             <a:avLst/>
           </a:prstGeom>
           <a:solidFill>
-            <a:srgbClr val="397B47"/>
+            <a:srgbClr val="2A7E49"/>
           </a:solidFill>
           <a:ln>
             <a:solidFill>
-              <a:srgbClr val="397B47"/>
+              <a:srgbClr val="2A7E49"/>
             </a:solidFill>
           </a:ln>
         </p:spPr>
@@ -4079,8 +4074,8 @@
         </p:nvSpPr>
         <p:spPr>
           <a:xfrm>
-            <a:off x="530352" y="1600200"/>
-            <a:ext cx="5797296" cy="6629400"/>
+            <a:off x="502920" y="1572768"/>
+            <a:ext cx="5806440" cy="6355080"/>
           </a:xfrm>
           <a:prstGeom prst="rect">
             <a:avLst/>
@@ -4094,104 +4089,84 @@
           <a:lstStyle/>
           <a:p>
             <a:pPr algn="l">
+              <a:lnSpc>
+                <a:spcPct val="115000"/>
+              </a:lnSpc>
               <a:spcAft>
                 <a:spcPts val="1000"/>
               </a:spcAft>
             </a:pPr>
             <a:r>
-              <a:rPr sz="1800">
-                <a:solidFill>
-                  <a:srgbClr val="1D1D1D"/>
-                </a:solidFill>
-              </a:rPr>
-              <a:t>• Vitality is the ability of a seed to produce a strong, healthy seedling.</a:t>
+              <a:rPr sz="1700">
+                <a:solidFill>
+                  <a:srgbClr val="1E1E1E"/>
+                </a:solidFill>
+              </a:rPr>
+              <a:t>• Vitality is the ability of a seed to produce a robust and healthy seedling under suitable conditions.</a:t>
             </a:r>
           </a:p>
           <a:p>
             <a:pPr algn="l">
+              <a:lnSpc>
+                <a:spcPct val="115000"/>
+              </a:lnSpc>
               <a:spcAft>
                 <a:spcPts val="1000"/>
               </a:spcAft>
             </a:pPr>
             <a:r>
-              <a:rPr sz="1800">
-                <a:solidFill>
-                  <a:srgbClr val="1D1D1D"/>
-                </a:solidFill>
-              </a:rPr>
-              <a:t>• Longevity (viability) is the period a seed remains capable of germination.</a:t>
+              <a:rPr sz="1700">
+                <a:solidFill>
+                  <a:srgbClr val="1E1E1E"/>
+                </a:solidFill>
+              </a:rPr>
+              <a:t>• Longevity or viability is the duration for which a seed remains alive and capable of germination during storage.</a:t>
             </a:r>
           </a:p>
           <a:p>
             <a:pPr algn="l">
+              <a:lnSpc>
+                <a:spcPct val="115000"/>
+              </a:lnSpc>
               <a:spcAft>
                 <a:spcPts val="1000"/>
               </a:spcAft>
             </a:pPr>
             <a:r>
-              <a:rPr sz="1800">
-                <a:solidFill>
-                  <a:srgbClr val="1D1D1D"/>
-                </a:solidFill>
-              </a:rPr>
-              <a:t>• Dormancy is a temporary resting state that prevents germination even in suitable conditions.</a:t>
-            </a:r>
-          </a:p>
-        </p:txBody>
-      </p:sp>
-      <p:sp>
-        <p:nvSpPr>
-          <p:cNvPr id="5" name="Rectangle 4"/>
-          <p:cNvSpPr/>
-          <p:nvPr/>
-        </p:nvSpPr>
-        <p:spPr>
-          <a:xfrm>
-            <a:off x="530352" y="8732520"/>
-            <a:ext cx="5797296" cy="2697480"/>
+              <a:rPr sz="1700">
+                <a:solidFill>
+                  <a:srgbClr val="1E1E1E"/>
+                </a:solidFill>
+              </a:rPr>
+              <a:t>• Dormancy is a protective resting state in which a viable seed temporarily resists germination until specific triggers are met.</a:t>
+            </a:r>
+          </a:p>
+        </p:txBody>
+      </p:sp>
+      <p:pic>
+        <p:nvPicPr>
+          <p:cNvPr id="5" name="Picture 4" descr="slide_13.png"/>
+          <p:cNvPicPr>
+            <a:picLocks noChangeAspect="1"/>
+          </p:cNvPicPr>
+          <p:nvPr/>
+        </p:nvPicPr>
+        <p:blipFill>
+          <a:blip r:embed="rId2"/>
+          <a:stretch>
+            <a:fillRect/>
+          </a:stretch>
+        </p:blipFill>
+        <p:spPr>
+          <a:xfrm>
+            <a:off x="502920" y="8183879"/>
+            <a:ext cx="5806440" cy="3063240"/>
           </a:xfrm>
           <a:prstGeom prst="rect">
             <a:avLst/>
           </a:prstGeom>
-          <a:solidFill>
-            <a:srgbClr val="F3F9F4"/>
-          </a:solidFill>
-          <a:ln w="22860">
-            <a:solidFill>
-              <a:srgbClr val="4E8C5B"/>
-            </a:solidFill>
-          </a:ln>
-        </p:spPr>
-        <p:style>
-          <a:lnRef idx="1">
-            <a:schemeClr val="accent1"/>
-          </a:lnRef>
-          <a:fillRef idx="3">
-            <a:schemeClr val="accent1"/>
-          </a:fillRef>
-          <a:effectRef idx="2">
-            <a:schemeClr val="accent1"/>
-          </a:effectRef>
-          <a:fontRef idx="minor">
-            <a:schemeClr val="lt1"/>
-          </a:fontRef>
-        </p:style>
-        <p:txBody>
-          <a:bodyPr rtlCol="0" anchor="ctr"/>
-          <a:lstStyle/>
-          <a:p>
-            <a:pPr algn="ctr"/>
-            <a:r>
-              <a:rPr b="1" sz="1600">
-                <a:solidFill>
-                  <a:srgbClr val="376D41"/>
-                </a:solidFill>
-              </a:rPr>
-              <a:t>Image Placeholder: Dormant seed vs germinated seed</a:t>
-            </a:r>
-          </a:p>
-        </p:txBody>
-      </p:sp>
+        </p:spPr>
+      </p:pic>
     </p:spTree>
   </p:cSld>
   <p:clrMapOvr>
@@ -4225,9 +4200,9 @@
             <a:avLst/>
           </a:prstGeom>
           <a:noFill/>
-          <a:ln w="27940">
+          <a:ln w="31750">
             <a:solidFill>
-              <a:srgbClr val="1F5F3A"/>
+              <a:srgbClr val="1D5C38"/>
             </a:solidFill>
           </a:ln>
         </p:spPr>
@@ -4261,18 +4236,18 @@
         </p:nvSpPr>
         <p:spPr>
           <a:xfrm>
-            <a:off x="438912" y="411480"/>
-            <a:ext cx="5980176" cy="914400"/>
+            <a:off x="411480" y="384048"/>
+            <a:ext cx="6035040" cy="960120"/>
           </a:xfrm>
           <a:prstGeom prst="roundRect">
             <a:avLst/>
           </a:prstGeom>
           <a:solidFill>
-            <a:srgbClr val="397B47"/>
+            <a:srgbClr val="2A7E49"/>
           </a:solidFill>
           <a:ln>
             <a:solidFill>
-              <a:srgbClr val="397B47"/>
+              <a:srgbClr val="2A7E49"/>
             </a:solidFill>
           </a:ln>
         </p:spPr>
@@ -4314,8 +4289,8 @@
         </p:nvSpPr>
         <p:spPr>
           <a:xfrm>
-            <a:off x="530352" y="1600200"/>
-            <a:ext cx="5797296" cy="6629400"/>
+            <a:off x="502920" y="1572768"/>
+            <a:ext cx="5806440" cy="6355080"/>
           </a:xfrm>
           <a:prstGeom prst="rect">
             <a:avLst/>
@@ -4329,89 +4304,84 @@
           <a:lstStyle/>
           <a:p>
             <a:pPr algn="l">
+              <a:lnSpc>
+                <a:spcPct val="115000"/>
+              </a:lnSpc>
               <a:spcAft>
                 <a:spcPts val="1000"/>
               </a:spcAft>
             </a:pPr>
             <a:r>
-              <a:rPr sz="1800">
-                <a:solidFill>
-                  <a:srgbClr val="1D1D1D"/>
-                </a:solidFill>
-              </a:rPr>
-              <a:t>• Urea is rich in nitrogen and is converted in soil into plant-available forms.</a:t>
+              <a:rPr sz="1700">
+                <a:solidFill>
+                  <a:srgbClr val="1E1E1E"/>
+                </a:solidFill>
+              </a:rPr>
+              <a:t>• Urea [CO(NH2)2] is transformed in soil into ammonium and later nitrate, both of which are usable nitrogen sources for plants.</a:t>
             </a:r>
           </a:p>
           <a:p>
             <a:pPr algn="l">
+              <a:lnSpc>
+                <a:spcPct val="115000"/>
+              </a:lnSpc>
               <a:spcAft>
                 <a:spcPts val="1000"/>
               </a:spcAft>
             </a:pPr>
             <a:r>
-              <a:rPr sz="1800">
-                <a:solidFill>
-                  <a:srgbClr val="1D1D1D"/>
-                </a:solidFill>
-              </a:rPr>
-              <a:t>• At balanced levels, it improves vegetative growth; at excessive levels, it can damage roots and foliage.</a:t>
-            </a:r>
-          </a:p>
-        </p:txBody>
-      </p:sp>
-      <p:sp>
-        <p:nvSpPr>
-          <p:cNvPr id="5" name="Rectangle 4"/>
-          <p:cNvSpPr/>
-          <p:nvPr/>
-        </p:nvSpPr>
-        <p:spPr>
-          <a:xfrm>
-            <a:off x="530352" y="8732520"/>
-            <a:ext cx="5797296" cy="2697480"/>
+              <a:rPr sz="1700">
+                <a:solidFill>
+                  <a:srgbClr val="1E1E1E"/>
+                </a:solidFill>
+              </a:rPr>
+              <a:t>• In moderate amounts, urea improves leaf area, chlorophyll concentration, and overall vegetative growth.</a:t>
+            </a:r>
+          </a:p>
+          <a:p>
+            <a:pPr algn="l">
+              <a:lnSpc>
+                <a:spcPct val="115000"/>
+              </a:lnSpc>
+              <a:spcAft>
+                <a:spcPts val="1000"/>
+              </a:spcAft>
+            </a:pPr>
+            <a:r>
+              <a:rPr sz="1700">
+                <a:solidFill>
+                  <a:srgbClr val="1E1E1E"/>
+                </a:solidFill>
+              </a:rPr>
+              <a:t>• In excess, it can increase salinity and ammonia stress, causing leaf scorch, weak roots, and reduced nutrient balance.</a:t>
+            </a:r>
+          </a:p>
+        </p:txBody>
+      </p:sp>
+      <p:pic>
+        <p:nvPicPr>
+          <p:cNvPr id="5" name="Picture 4" descr="slide_14.png"/>
+          <p:cNvPicPr>
+            <a:picLocks noChangeAspect="1"/>
+          </p:cNvPicPr>
+          <p:nvPr/>
+        </p:nvPicPr>
+        <p:blipFill>
+          <a:blip r:embed="rId2"/>
+          <a:stretch>
+            <a:fillRect/>
+          </a:stretch>
+        </p:blipFill>
+        <p:spPr>
+          <a:xfrm>
+            <a:off x="502920" y="8183879"/>
+            <a:ext cx="5806440" cy="3063240"/>
           </a:xfrm>
           <a:prstGeom prst="rect">
             <a:avLst/>
           </a:prstGeom>
-          <a:solidFill>
-            <a:srgbClr val="F3F9F4"/>
-          </a:solidFill>
-          <a:ln w="22860">
-            <a:solidFill>
-              <a:srgbClr val="4E8C5B"/>
-            </a:solidFill>
-          </a:ln>
-        </p:spPr>
-        <p:style>
-          <a:lnRef idx="1">
-            <a:schemeClr val="accent1"/>
-          </a:lnRef>
-          <a:fillRef idx="3">
-            <a:schemeClr val="accent1"/>
-          </a:fillRef>
-          <a:effectRef idx="2">
-            <a:schemeClr val="accent1"/>
-          </a:effectRef>
-          <a:fontRef idx="minor">
-            <a:schemeClr val="lt1"/>
-          </a:fontRef>
-        </p:style>
-        <p:txBody>
-          <a:bodyPr rtlCol="0" anchor="ctr"/>
-          <a:lstStyle/>
-          <a:p>
-            <a:pPr algn="ctr"/>
-            <a:r>
-              <a:rPr b="1" sz="1600">
-                <a:solidFill>
-                  <a:srgbClr val="376D41"/>
-                </a:solidFill>
-              </a:rPr>
-              <a:t>Image Placeholder: Nitrogen transformation and plant uptake</a:t>
-            </a:r>
-          </a:p>
-        </p:txBody>
-      </p:sp>
+        </p:spPr>
+      </p:pic>
     </p:spTree>
   </p:cSld>
   <p:clrMapOvr>
@@ -4445,9 +4415,9 @@
             <a:avLst/>
           </a:prstGeom>
           <a:noFill/>
-          <a:ln w="27940">
+          <a:ln w="31750">
             <a:solidFill>
-              <a:srgbClr val="1F5F3A"/>
+              <a:srgbClr val="1D5C38"/>
             </a:solidFill>
           </a:ln>
         </p:spPr>
@@ -4481,18 +4451,18 @@
         </p:nvSpPr>
         <p:spPr>
           <a:xfrm>
-            <a:off x="438912" y="411480"/>
-            <a:ext cx="5980176" cy="914400"/>
+            <a:off x="411480" y="384048"/>
+            <a:ext cx="6035040" cy="960120"/>
           </a:xfrm>
           <a:prstGeom prst="roundRect">
             <a:avLst/>
           </a:prstGeom>
           <a:solidFill>
-            <a:srgbClr val="397B47"/>
+            <a:srgbClr val="2A7E49"/>
           </a:solidFill>
           <a:ln>
             <a:solidFill>
-              <a:srgbClr val="397B47"/>
+              <a:srgbClr val="2A7E49"/>
             </a:solidFill>
           </a:ln>
         </p:spPr>
@@ -4534,8 +4504,8 @@
         </p:nvSpPr>
         <p:spPr>
           <a:xfrm>
-            <a:off x="530352" y="1600200"/>
-            <a:ext cx="5797296" cy="6629400"/>
+            <a:off x="502920" y="1572768"/>
+            <a:ext cx="5806440" cy="6355080"/>
           </a:xfrm>
           <a:prstGeom prst="rect">
             <a:avLst/>
@@ -4549,89 +4519,84 @@
           <a:lstStyle/>
           <a:p>
             <a:pPr algn="l">
+              <a:lnSpc>
+                <a:spcPct val="115000"/>
+              </a:lnSpc>
               <a:spcAft>
                 <a:spcPts val="1000"/>
               </a:spcAft>
             </a:pPr>
             <a:r>
-              <a:rPr sz="1800">
-                <a:solidFill>
-                  <a:srgbClr val="1D1D1D"/>
-                </a:solidFill>
-              </a:rPr>
-              <a:t>• Apply urea in measured doses based on crop stage and soil condition.</a:t>
+              <a:rPr sz="1700">
+                <a:solidFill>
+                  <a:srgbClr val="1E1E1E"/>
+                </a:solidFill>
+              </a:rPr>
+              <a:t>• Apply urea according to crop stage, soil condition, and recommended agronomic dosage rather than random estimation.</a:t>
             </a:r>
           </a:p>
           <a:p>
             <a:pPr algn="l">
+              <a:lnSpc>
+                <a:spcPct val="115000"/>
+              </a:lnSpc>
               <a:spcAft>
                 <a:spcPts val="1000"/>
               </a:spcAft>
             </a:pPr>
             <a:r>
-              <a:rPr sz="1800">
-                <a:solidFill>
-                  <a:srgbClr val="1D1D1D"/>
-                </a:solidFill>
-              </a:rPr>
-              <a:t>• Place it near the root zone, avoid over-application, and irrigate after use to reduce nitrogen loss.</a:t>
-            </a:r>
-          </a:p>
-        </p:txBody>
-      </p:sp>
-      <p:sp>
-        <p:nvSpPr>
-          <p:cNvPr id="5" name="Rectangle 4"/>
-          <p:cNvSpPr/>
-          <p:nvPr/>
-        </p:nvSpPr>
-        <p:spPr>
-          <a:xfrm>
-            <a:off x="530352" y="8732520"/>
-            <a:ext cx="5797296" cy="2697480"/>
+              <a:rPr sz="1700">
+                <a:solidFill>
+                  <a:srgbClr val="1E1E1E"/>
+                </a:solidFill>
+              </a:rPr>
+              <a:t>• Split application is often more effective than a single heavy dose because it reduces losses and improves nutrient uptake.</a:t>
+            </a:r>
+          </a:p>
+          <a:p>
+            <a:pPr algn="l">
+              <a:lnSpc>
+                <a:spcPct val="115000"/>
+              </a:lnSpc>
+              <a:spcAft>
+                <a:spcPts val="1000"/>
+              </a:spcAft>
+            </a:pPr>
+            <a:r>
+              <a:rPr sz="1700">
+                <a:solidFill>
+                  <a:srgbClr val="1E1E1E"/>
+                </a:solidFill>
+              </a:rPr>
+              <a:t>• Incorporate urea into moist soil and irrigate after application to minimize volatilization and maximize root access.</a:t>
+            </a:r>
+          </a:p>
+        </p:txBody>
+      </p:sp>
+      <p:pic>
+        <p:nvPicPr>
+          <p:cNvPr id="5" name="Picture 4" descr="slide_15.png"/>
+          <p:cNvPicPr>
+            <a:picLocks noChangeAspect="1"/>
+          </p:cNvPicPr>
+          <p:nvPr/>
+        </p:nvPicPr>
+        <p:blipFill>
+          <a:blip r:embed="rId2"/>
+          <a:stretch>
+            <a:fillRect/>
+          </a:stretch>
+        </p:blipFill>
+        <p:spPr>
+          <a:xfrm>
+            <a:off x="502920" y="8183879"/>
+            <a:ext cx="5806440" cy="3063240"/>
           </a:xfrm>
           <a:prstGeom prst="rect">
             <a:avLst/>
           </a:prstGeom>
-          <a:solidFill>
-            <a:srgbClr val="F3F9F4"/>
-          </a:solidFill>
-          <a:ln w="22860">
-            <a:solidFill>
-              <a:srgbClr val="4E8C5B"/>
-            </a:solidFill>
-          </a:ln>
-        </p:spPr>
-        <p:style>
-          <a:lnRef idx="1">
-            <a:schemeClr val="accent1"/>
-          </a:lnRef>
-          <a:fillRef idx="3">
-            <a:schemeClr val="accent1"/>
-          </a:fillRef>
-          <a:effectRef idx="2">
-            <a:schemeClr val="accent1"/>
-          </a:effectRef>
-          <a:fontRef idx="minor">
-            <a:schemeClr val="lt1"/>
-          </a:fontRef>
-        </p:style>
-        <p:txBody>
-          <a:bodyPr rtlCol="0" anchor="ctr"/>
-          <a:lstStyle/>
-          <a:p>
-            <a:pPr algn="ctr"/>
-            <a:r>
-              <a:rPr b="1" sz="1600">
-                <a:solidFill>
-                  <a:srgbClr val="376D41"/>
-                </a:solidFill>
-              </a:rPr>
-              <a:t>Image Placeholder: Safe fertilizer application method</a:t>
-            </a:r>
-          </a:p>
-        </p:txBody>
-      </p:sp>
+        </p:spPr>
+      </p:pic>
     </p:spTree>
   </p:cSld>
   <p:clrMapOvr>
@@ -4665,9 +4630,9 @@
             <a:avLst/>
           </a:prstGeom>
           <a:noFill/>
-          <a:ln w="27940">
+          <a:ln w="31750">
             <a:solidFill>
-              <a:srgbClr val="1F5F3A"/>
+              <a:srgbClr val="1D5C38"/>
             </a:solidFill>
           </a:ln>
         </p:spPr>
@@ -4701,18 +4666,18 @@
         </p:nvSpPr>
         <p:spPr>
           <a:xfrm>
-            <a:off x="438912" y="411480"/>
-            <a:ext cx="5980176" cy="914400"/>
+            <a:off x="411480" y="384048"/>
+            <a:ext cx="6035040" cy="960120"/>
           </a:xfrm>
           <a:prstGeom prst="roundRect">
             <a:avLst/>
           </a:prstGeom>
           <a:solidFill>
-            <a:srgbClr val="397B47"/>
+            <a:srgbClr val="2A7E49"/>
           </a:solidFill>
           <a:ln>
             <a:solidFill>
-              <a:srgbClr val="397B47"/>
+              <a:srgbClr val="2A7E49"/>
             </a:solidFill>
           </a:ln>
         </p:spPr>
@@ -4754,8 +4719,8 @@
         </p:nvSpPr>
         <p:spPr>
           <a:xfrm>
-            <a:off x="530352" y="1600200"/>
-            <a:ext cx="5797296" cy="6629400"/>
+            <a:off x="502920" y="1572768"/>
+            <a:ext cx="5806440" cy="6355080"/>
           </a:xfrm>
           <a:prstGeom prst="rect">
             <a:avLst/>
@@ -4769,89 +4734,84 @@
           <a:lstStyle/>
           <a:p>
             <a:pPr algn="l">
+              <a:lnSpc>
+                <a:spcPct val="115000"/>
+              </a:lnSpc>
               <a:spcAft>
                 <a:spcPts val="1000"/>
               </a:spcAft>
             </a:pPr>
             <a:r>
-              <a:rPr sz="1800">
-                <a:solidFill>
-                  <a:srgbClr val="1D1D1D"/>
-                </a:solidFill>
-              </a:rPr>
-              <a:t>• High nitrogen content supports rapid vegetative growth and greener leaves.</a:t>
+              <a:rPr sz="1700">
+                <a:solidFill>
+                  <a:srgbClr val="1E1E1E"/>
+                </a:solidFill>
+              </a:rPr>
+              <a:t>• Urea contains high nitrogen concentration, making it efficient for correcting nitrogen deficiency and promoting rapid vegetative growth.</a:t>
             </a:r>
           </a:p>
           <a:p>
             <a:pPr algn="l">
+              <a:lnSpc>
+                <a:spcPct val="115000"/>
+              </a:lnSpc>
               <a:spcAft>
                 <a:spcPts val="1000"/>
               </a:spcAft>
             </a:pPr>
             <a:r>
-              <a:rPr sz="1800">
-                <a:solidFill>
-                  <a:srgbClr val="1D1D1D"/>
-                </a:solidFill>
-              </a:rPr>
-              <a:t>• It is economical, easy to handle, and effective when integrated with balanced nutrient management.</a:t>
-            </a:r>
-          </a:p>
-        </p:txBody>
-      </p:sp>
-      <p:sp>
-        <p:nvSpPr>
-          <p:cNvPr id="5" name="Rectangle 4"/>
-          <p:cNvSpPr/>
-          <p:nvPr/>
-        </p:nvSpPr>
-        <p:spPr>
-          <a:xfrm>
-            <a:off x="530352" y="8732520"/>
-            <a:ext cx="5797296" cy="2697480"/>
+              <a:rPr sz="1700">
+                <a:solidFill>
+                  <a:srgbClr val="1E1E1E"/>
+                </a:solidFill>
+              </a:rPr>
+              <a:t>• It is comparatively economical, easy to store, and widely available, which supports large-scale agricultural use.</a:t>
+            </a:r>
+          </a:p>
+          <a:p>
+            <a:pPr algn="l">
+              <a:lnSpc>
+                <a:spcPct val="115000"/>
+              </a:lnSpc>
+              <a:spcAft>
+                <a:spcPts val="1000"/>
+              </a:spcAft>
+            </a:pPr>
+            <a:r>
+              <a:rPr sz="1700">
+                <a:solidFill>
+                  <a:srgbClr val="1E1E1E"/>
+                </a:solidFill>
+              </a:rPr>
+              <a:t>• When integrated with balanced nutrient management, urea can improve yield, leaf quality, and crop uniformity.</a:t>
+            </a:r>
+          </a:p>
+        </p:txBody>
+      </p:sp>
+      <p:pic>
+        <p:nvPicPr>
+          <p:cNvPr id="5" name="Picture 4" descr="slide_16.png"/>
+          <p:cNvPicPr>
+            <a:picLocks noChangeAspect="1"/>
+          </p:cNvPicPr>
+          <p:nvPr/>
+        </p:nvPicPr>
+        <p:blipFill>
+          <a:blip r:embed="rId2"/>
+          <a:stretch>
+            <a:fillRect/>
+          </a:stretch>
+        </p:blipFill>
+        <p:spPr>
+          <a:xfrm>
+            <a:off x="502920" y="8183879"/>
+            <a:ext cx="5806440" cy="3063240"/>
           </a:xfrm>
           <a:prstGeom prst="rect">
             <a:avLst/>
           </a:prstGeom>
-          <a:solidFill>
-            <a:srgbClr val="F3F9F4"/>
-          </a:solidFill>
-          <a:ln w="22860">
-            <a:solidFill>
-              <a:srgbClr val="4E8C5B"/>
-            </a:solidFill>
-          </a:ln>
-        </p:spPr>
-        <p:style>
-          <a:lnRef idx="1">
-            <a:schemeClr val="accent1"/>
-          </a:lnRef>
-          <a:fillRef idx="3">
-            <a:schemeClr val="accent1"/>
-          </a:fillRef>
-          <a:effectRef idx="2">
-            <a:schemeClr val="accent1"/>
-          </a:effectRef>
-          <a:fontRef idx="minor">
-            <a:schemeClr val="lt1"/>
-          </a:fontRef>
-        </p:style>
-        <p:txBody>
-          <a:bodyPr rtlCol="0" anchor="ctr"/>
-          <a:lstStyle/>
-          <a:p>
-            <a:pPr algn="ctr"/>
-            <a:r>
-              <a:rPr b="1" sz="1600">
-                <a:solidFill>
-                  <a:srgbClr val="376D41"/>
-                </a:solidFill>
-              </a:rPr>
-              <a:t>Image Placeholder: Healthy high-yield field</a:t>
-            </a:r>
-          </a:p>
-        </p:txBody>
-      </p:sp>
+        </p:spPr>
+      </p:pic>
     </p:spTree>
   </p:cSld>
   <p:clrMapOvr>
@@ -4885,9 +4845,9 @@
             <a:avLst/>
           </a:prstGeom>
           <a:noFill/>
-          <a:ln w="27940">
+          <a:ln w="31750">
             <a:solidFill>
-              <a:srgbClr val="1F5F3A"/>
+              <a:srgbClr val="1D5C38"/>
             </a:solidFill>
           </a:ln>
         </p:spPr>
@@ -4921,18 +4881,18 @@
         </p:nvSpPr>
         <p:spPr>
           <a:xfrm>
-            <a:off x="438912" y="411480"/>
-            <a:ext cx="5980176" cy="914400"/>
+            <a:off x="411480" y="384048"/>
+            <a:ext cx="6035040" cy="960120"/>
           </a:xfrm>
           <a:prstGeom prst="roundRect">
             <a:avLst/>
           </a:prstGeom>
           <a:solidFill>
-            <a:srgbClr val="397B47"/>
+            <a:srgbClr val="2A7E49"/>
           </a:solidFill>
           <a:ln>
             <a:solidFill>
-              <a:srgbClr val="397B47"/>
+              <a:srgbClr val="2A7E49"/>
             </a:solidFill>
           </a:ln>
         </p:spPr>
@@ -4974,8 +4934,8 @@
         </p:nvSpPr>
         <p:spPr>
           <a:xfrm>
-            <a:off x="530352" y="1600200"/>
-            <a:ext cx="5797296" cy="6629400"/>
+            <a:off x="502920" y="1572768"/>
+            <a:ext cx="5806440" cy="6355080"/>
           </a:xfrm>
           <a:prstGeom prst="rect">
             <a:avLst/>
@@ -4989,89 +4949,84 @@
           <a:lstStyle/>
           <a:p>
             <a:pPr algn="l">
+              <a:lnSpc>
+                <a:spcPct val="115000"/>
+              </a:lnSpc>
               <a:spcAft>
                 <a:spcPts val="1000"/>
               </a:spcAft>
             </a:pPr>
             <a:r>
-              <a:rPr sz="1800">
-                <a:solidFill>
-                  <a:srgbClr val="1D1D1D"/>
-                </a:solidFill>
-              </a:rPr>
-              <a:t>• Overuse of chemical fertilizers may degrade soil health and reduce beneficial microorganisms.</a:t>
+              <a:rPr sz="1700">
+                <a:solidFill>
+                  <a:srgbClr val="1E1E1E"/>
+                </a:solidFill>
+              </a:rPr>
+              <a:t>• Overuse of chemical fertilizers can degrade soil structure, reduce beneficial microbial populations, and create nutrient imbalance.</a:t>
             </a:r>
           </a:p>
           <a:p>
             <a:pPr algn="l">
+              <a:lnSpc>
+                <a:spcPct val="115000"/>
+              </a:lnSpc>
               <a:spcAft>
                 <a:spcPts val="1000"/>
               </a:spcAft>
             </a:pPr>
             <a:r>
-              <a:rPr sz="1800">
-                <a:solidFill>
-                  <a:srgbClr val="1D1D1D"/>
-                </a:solidFill>
-              </a:rPr>
-              <a:t>• Runoff and leaching can pollute water bodies and create long-term environmental concerns.</a:t>
-            </a:r>
-          </a:p>
-        </p:txBody>
-      </p:sp>
-      <p:sp>
-        <p:nvSpPr>
-          <p:cNvPr id="5" name="Rectangle 4"/>
-          <p:cNvSpPr/>
-          <p:nvPr/>
-        </p:nvSpPr>
-        <p:spPr>
-          <a:xfrm>
-            <a:off x="530352" y="8732520"/>
-            <a:ext cx="5797296" cy="2697480"/>
+              <a:rPr sz="1700">
+                <a:solidFill>
+                  <a:srgbClr val="1E1E1E"/>
+                </a:solidFill>
+              </a:rPr>
+              <a:t>• Excess nitrate may leach into groundwater, while surface runoff can trigger eutrophication in ponds, lakes, and rivers.</a:t>
+            </a:r>
+          </a:p>
+          <a:p>
+            <a:pPr algn="l">
+              <a:lnSpc>
+                <a:spcPct val="115000"/>
+              </a:lnSpc>
+              <a:spcAft>
+                <a:spcPts val="1000"/>
+              </a:spcAft>
+            </a:pPr>
+            <a:r>
+              <a:rPr sz="1700">
+                <a:solidFill>
+                  <a:srgbClr val="1E1E1E"/>
+                </a:solidFill>
+              </a:rPr>
+              <a:t>• Long-term dependence on high doses can lower sustainability and increase environmental risk.</a:t>
+            </a:r>
+          </a:p>
+        </p:txBody>
+      </p:sp>
+      <p:pic>
+        <p:nvPicPr>
+          <p:cNvPr id="5" name="Picture 4" descr="slide_17.png"/>
+          <p:cNvPicPr>
+            <a:picLocks noChangeAspect="1"/>
+          </p:cNvPicPr>
+          <p:nvPr/>
+        </p:nvPicPr>
+        <p:blipFill>
+          <a:blip r:embed="rId2"/>
+          <a:stretch>
+            <a:fillRect/>
+          </a:stretch>
+        </p:blipFill>
+        <p:spPr>
+          <a:xfrm>
+            <a:off x="502920" y="8183879"/>
+            <a:ext cx="5806440" cy="3063240"/>
           </a:xfrm>
           <a:prstGeom prst="rect">
             <a:avLst/>
           </a:prstGeom>
-          <a:solidFill>
-            <a:srgbClr val="F3F9F4"/>
-          </a:solidFill>
-          <a:ln w="22860">
-            <a:solidFill>
-              <a:srgbClr val="4E8C5B"/>
-            </a:solidFill>
-          </a:ln>
-        </p:spPr>
-        <p:style>
-          <a:lnRef idx="1">
-            <a:schemeClr val="accent1"/>
-          </a:lnRef>
-          <a:fillRef idx="3">
-            <a:schemeClr val="accent1"/>
-          </a:fillRef>
-          <a:effectRef idx="2">
-            <a:schemeClr val="accent1"/>
-          </a:effectRef>
-          <a:fontRef idx="minor">
-            <a:schemeClr val="lt1"/>
-          </a:fontRef>
-        </p:style>
-        <p:txBody>
-          <a:bodyPr rtlCol="0" anchor="ctr"/>
-          <a:lstStyle/>
-          <a:p>
-            <a:pPr algn="ctr"/>
-            <a:r>
-              <a:rPr b="1" sz="1600">
-                <a:solidFill>
-                  <a:srgbClr val="376D41"/>
-                </a:solidFill>
-              </a:rPr>
-              <a:t>Image Placeholder: Fertilizer runoff and pollution</a:t>
-            </a:r>
-          </a:p>
-        </p:txBody>
-      </p:sp>
+        </p:spPr>
+      </p:pic>
     </p:spTree>
   </p:cSld>
   <p:clrMapOvr>
@@ -5105,9 +5060,9 @@
             <a:avLst/>
           </a:prstGeom>
           <a:noFill/>
-          <a:ln w="27940">
+          <a:ln w="31750">
             <a:solidFill>
-              <a:srgbClr val="1F5F3A"/>
+              <a:srgbClr val="1D5C38"/>
             </a:solidFill>
           </a:ln>
         </p:spPr>
@@ -5141,18 +5096,18 @@
         </p:nvSpPr>
         <p:spPr>
           <a:xfrm>
-            <a:off x="438912" y="411480"/>
-            <a:ext cx="5980176" cy="914400"/>
+            <a:off x="411480" y="384048"/>
+            <a:ext cx="6035040" cy="960120"/>
           </a:xfrm>
           <a:prstGeom prst="roundRect">
             <a:avLst/>
           </a:prstGeom>
           <a:solidFill>
-            <a:srgbClr val="397B47"/>
+            <a:srgbClr val="2A7E49"/>
           </a:solidFill>
           <a:ln>
             <a:solidFill>
-              <a:srgbClr val="397B47"/>
+              <a:srgbClr val="2A7E49"/>
             </a:solidFill>
           </a:ln>
         </p:spPr>
@@ -5194,8 +5149,8 @@
         </p:nvSpPr>
         <p:spPr>
           <a:xfrm>
-            <a:off x="530352" y="1600200"/>
-            <a:ext cx="5797296" cy="6629400"/>
+            <a:off x="502920" y="1572768"/>
+            <a:ext cx="5806440" cy="6355080"/>
           </a:xfrm>
           <a:prstGeom prst="rect">
             <a:avLst/>
@@ -5209,89 +5164,84 @@
           <a:lstStyle/>
           <a:p>
             <a:pPr algn="l">
+              <a:lnSpc>
+                <a:spcPct val="115000"/>
+              </a:lnSpc>
               <a:spcAft>
                 <a:spcPts val="1000"/>
               </a:spcAft>
             </a:pPr>
             <a:r>
-              <a:rPr sz="1800">
-                <a:solidFill>
-                  <a:srgbClr val="1D1D1D"/>
-                </a:solidFill>
-              </a:rPr>
-              <a:t>• Seeds, pots or trays, soil, urea fertilizer, measuring spoon, labels, watering can, ruler, and observation notebook.</a:t>
+              <a:rPr sz="1700">
+                <a:solidFill>
+                  <a:srgbClr val="1E1E1E"/>
+                </a:solidFill>
+              </a:rPr>
+              <a:t>• Required materials include uniform seeds, equal-sized pots, measured soil, urea fertilizer, labels, and a watering can.</a:t>
             </a:r>
           </a:p>
           <a:p>
             <a:pPr algn="l">
+              <a:lnSpc>
+                <a:spcPct val="115000"/>
+              </a:lnSpc>
               <a:spcAft>
                 <a:spcPts val="1000"/>
               </a:spcAft>
             </a:pPr>
             <a:r>
-              <a:rPr sz="1800">
-                <a:solidFill>
-                  <a:srgbClr val="1D1D1D"/>
-                </a:solidFill>
-              </a:rPr>
-              <a:t>• All apparatus should be standardized to ensure fair comparison across treatments.</a:t>
-            </a:r>
-          </a:p>
-        </p:txBody>
-      </p:sp>
-      <p:sp>
-        <p:nvSpPr>
-          <p:cNvPr id="5" name="Rectangle 4"/>
-          <p:cNvSpPr/>
-          <p:nvPr/>
-        </p:nvSpPr>
-        <p:spPr>
-          <a:xfrm>
-            <a:off x="530352" y="8732520"/>
-            <a:ext cx="5797296" cy="2697480"/>
+              <a:rPr sz="1700">
+                <a:solidFill>
+                  <a:srgbClr val="1E1E1E"/>
+                </a:solidFill>
+              </a:rPr>
+              <a:t>• Measurement tools such as a ruler, notebook, and weighing spoon are needed to maintain data accuracy and consistency.</a:t>
+            </a:r>
+          </a:p>
+          <a:p>
+            <a:pPr algn="l">
+              <a:lnSpc>
+                <a:spcPct val="115000"/>
+              </a:lnSpc>
+              <a:spcAft>
+                <a:spcPts val="1000"/>
+              </a:spcAft>
+            </a:pPr>
+            <a:r>
+              <a:rPr sz="1700">
+                <a:solidFill>
+                  <a:srgbClr val="1E1E1E"/>
+                </a:solidFill>
+              </a:rPr>
+              <a:t>• Protective gloves are recommended for safe fertilizer handling during the experiment.</a:t>
+            </a:r>
+          </a:p>
+        </p:txBody>
+      </p:sp>
+      <p:pic>
+        <p:nvPicPr>
+          <p:cNvPr id="5" name="Picture 4" descr="slide_18.png"/>
+          <p:cNvPicPr>
+            <a:picLocks noChangeAspect="1"/>
+          </p:cNvPicPr>
+          <p:nvPr/>
+        </p:nvPicPr>
+        <p:blipFill>
+          <a:blip r:embed="rId2"/>
+          <a:stretch>
+            <a:fillRect/>
+          </a:stretch>
+        </p:blipFill>
+        <p:spPr>
+          <a:xfrm>
+            <a:off x="502920" y="8183879"/>
+            <a:ext cx="5806440" cy="3063240"/>
           </a:xfrm>
           <a:prstGeom prst="rect">
             <a:avLst/>
           </a:prstGeom>
-          <a:solidFill>
-            <a:srgbClr val="F3F9F4"/>
-          </a:solidFill>
-          <a:ln w="22860">
-            <a:solidFill>
-              <a:srgbClr val="4E8C5B"/>
-            </a:solidFill>
-          </a:ln>
-        </p:spPr>
-        <p:style>
-          <a:lnRef idx="1">
-            <a:schemeClr val="accent1"/>
-          </a:lnRef>
-          <a:fillRef idx="3">
-            <a:schemeClr val="accent1"/>
-          </a:fillRef>
-          <a:effectRef idx="2">
-            <a:schemeClr val="accent1"/>
-          </a:effectRef>
-          <a:fontRef idx="minor">
-            <a:schemeClr val="lt1"/>
-          </a:fontRef>
-        </p:style>
-        <p:txBody>
-          <a:bodyPr rtlCol="0" anchor="ctr"/>
-          <a:lstStyle/>
-          <a:p>
-            <a:pPr algn="ctr"/>
-            <a:r>
-              <a:rPr b="1" sz="1600">
-                <a:solidFill>
-                  <a:srgbClr val="376D41"/>
-                </a:solidFill>
-              </a:rPr>
-              <a:t>Image Placeholder: Apparatus layout on table</a:t>
-            </a:r>
-          </a:p>
-        </p:txBody>
-      </p:sp>
+        </p:spPr>
+      </p:pic>
     </p:spTree>
   </p:cSld>
   <p:clrMapOvr>
@@ -5325,9 +5275,9 @@
             <a:avLst/>
           </a:prstGeom>
           <a:noFill/>
-          <a:ln w="27940">
+          <a:ln w="31750">
             <a:solidFill>
-              <a:srgbClr val="1F5F3A"/>
+              <a:srgbClr val="1D5C38"/>
             </a:solidFill>
           </a:ln>
         </p:spPr>
@@ -5361,18 +5311,18 @@
         </p:nvSpPr>
         <p:spPr>
           <a:xfrm>
-            <a:off x="438912" y="411480"/>
-            <a:ext cx="5980176" cy="914400"/>
+            <a:off x="411480" y="384048"/>
+            <a:ext cx="6035040" cy="960120"/>
           </a:xfrm>
           <a:prstGeom prst="roundRect">
             <a:avLst/>
           </a:prstGeom>
           <a:solidFill>
-            <a:srgbClr val="397B47"/>
+            <a:srgbClr val="2A7E49"/>
           </a:solidFill>
           <a:ln>
             <a:solidFill>
-              <a:srgbClr val="397B47"/>
+              <a:srgbClr val="2A7E49"/>
             </a:solidFill>
           </a:ln>
         </p:spPr>
@@ -5414,8 +5364,8 @@
         </p:nvSpPr>
         <p:spPr>
           <a:xfrm>
-            <a:off x="530352" y="1600200"/>
-            <a:ext cx="5797296" cy="6629400"/>
+            <a:off x="502920" y="1572768"/>
+            <a:ext cx="5806440" cy="6355080"/>
           </a:xfrm>
           <a:prstGeom prst="rect">
             <a:avLst/>
@@ -5429,89 +5379,84 @@
           <a:lstStyle/>
           <a:p>
             <a:pPr algn="l">
+              <a:lnSpc>
+                <a:spcPct val="115000"/>
+              </a:lnSpc>
               <a:spcAft>
                 <a:spcPts val="1000"/>
               </a:spcAft>
             </a:pPr>
             <a:r>
-              <a:rPr sz="1800">
-                <a:solidFill>
-                  <a:srgbClr val="1D1D1D"/>
-                </a:solidFill>
-              </a:rPr>
-              <a:t>• Prepare equal pots, sow the same seed type, and create one control plus multiple urea-treatment groups.</a:t>
+              <a:rPr sz="1700">
+                <a:solidFill>
+                  <a:srgbClr val="1E1E1E"/>
+                </a:solidFill>
+              </a:rPr>
+              <a:t>• Prepare equal pots with the same soil quantity and sow equal numbers of seeds from a single seed batch.</a:t>
             </a:r>
           </a:p>
           <a:p>
             <a:pPr algn="l">
+              <a:lnSpc>
+                <a:spcPct val="115000"/>
+              </a:lnSpc>
               <a:spcAft>
                 <a:spcPts val="1000"/>
               </a:spcAft>
             </a:pPr>
             <a:r>
-              <a:rPr sz="1800">
-                <a:solidFill>
-                  <a:srgbClr val="1D1D1D"/>
-                </a:solidFill>
-              </a:rPr>
-              <a:t>• Maintain equal water and light, then record germination and growth data for at least two weeks.</a:t>
-            </a:r>
-          </a:p>
-        </p:txBody>
-      </p:sp>
-      <p:sp>
-        <p:nvSpPr>
-          <p:cNvPr id="5" name="Rectangle 4"/>
-          <p:cNvSpPr/>
-          <p:nvPr/>
-        </p:nvSpPr>
-        <p:spPr>
-          <a:xfrm>
-            <a:off x="530352" y="8732520"/>
-            <a:ext cx="5797296" cy="2697480"/>
+              <a:rPr sz="1700">
+                <a:solidFill>
+                  <a:srgbClr val="1E1E1E"/>
+                </a:solidFill>
+              </a:rPr>
+              <a:t>• Create one control group (without urea) and multiple treatment groups with increasing urea concentrations.</a:t>
+            </a:r>
+          </a:p>
+          <a:p>
+            <a:pPr algn="l">
+              <a:lnSpc>
+                <a:spcPct val="115000"/>
+              </a:lnSpc>
+              <a:spcAft>
+                <a:spcPts val="1000"/>
+              </a:spcAft>
+            </a:pPr>
+            <a:r>
+              <a:rPr sz="1700">
+                <a:solidFill>
+                  <a:srgbClr val="1E1E1E"/>
+                </a:solidFill>
+              </a:rPr>
+              <a:t>• Maintain equal water, light, and temperature, then record germination, plant height, leaf count, and visible health over time.</a:t>
+            </a:r>
+          </a:p>
+        </p:txBody>
+      </p:sp>
+      <p:pic>
+        <p:nvPicPr>
+          <p:cNvPr id="5" name="Picture 4" descr="slide_19.png"/>
+          <p:cNvPicPr>
+            <a:picLocks noChangeAspect="1"/>
+          </p:cNvPicPr>
+          <p:nvPr/>
+        </p:nvPicPr>
+        <p:blipFill>
+          <a:blip r:embed="rId2"/>
+          <a:stretch>
+            <a:fillRect/>
+          </a:stretch>
+        </p:blipFill>
+        <p:spPr>
+          <a:xfrm>
+            <a:off x="502920" y="8183879"/>
+            <a:ext cx="5806440" cy="3063240"/>
           </a:xfrm>
           <a:prstGeom prst="rect">
             <a:avLst/>
           </a:prstGeom>
-          <a:solidFill>
-            <a:srgbClr val="F3F9F4"/>
-          </a:solidFill>
-          <a:ln w="22860">
-            <a:solidFill>
-              <a:srgbClr val="4E8C5B"/>
-            </a:solidFill>
-          </a:ln>
-        </p:spPr>
-        <p:style>
-          <a:lnRef idx="1">
-            <a:schemeClr val="accent1"/>
-          </a:lnRef>
-          <a:fillRef idx="3">
-            <a:schemeClr val="accent1"/>
-          </a:fillRef>
-          <a:effectRef idx="2">
-            <a:schemeClr val="accent1"/>
-          </a:effectRef>
-          <a:fontRef idx="minor">
-            <a:schemeClr val="lt1"/>
-          </a:fontRef>
-        </p:style>
-        <p:txBody>
-          <a:bodyPr rtlCol="0" anchor="ctr"/>
-          <a:lstStyle/>
-          <a:p>
-            <a:pPr algn="ctr"/>
-            <a:r>
-              <a:rPr b="1" sz="1600">
-                <a:solidFill>
-                  <a:srgbClr val="376D41"/>
-                </a:solidFill>
-              </a:rPr>
-              <a:t>Image Placeholder: Experimental workflow steps</a:t>
-            </a:r>
-          </a:p>
-        </p:txBody>
-      </p:sp>
+        </p:spPr>
+      </p:pic>
     </p:spTree>
   </p:cSld>
   <p:clrMapOvr>
@@ -5545,9 +5490,9 @@
             <a:avLst/>
           </a:prstGeom>
           <a:noFill/>
-          <a:ln w="27940">
+          <a:ln w="31750">
             <a:solidFill>
-              <a:srgbClr val="1F5F3A"/>
+              <a:srgbClr val="1D5C38"/>
             </a:solidFill>
           </a:ln>
         </p:spPr>
@@ -5581,18 +5526,18 @@
         </p:nvSpPr>
         <p:spPr>
           <a:xfrm>
-            <a:off x="438912" y="411480"/>
-            <a:ext cx="5980176" cy="914400"/>
+            <a:off x="411480" y="384048"/>
+            <a:ext cx="6035040" cy="960120"/>
           </a:xfrm>
           <a:prstGeom prst="roundRect">
             <a:avLst/>
           </a:prstGeom>
           <a:solidFill>
-            <a:srgbClr val="397B47"/>
+            <a:srgbClr val="2A7E49"/>
           </a:solidFill>
           <a:ln>
             <a:solidFill>
-              <a:srgbClr val="397B47"/>
+              <a:srgbClr val="2A7E49"/>
             </a:solidFill>
           </a:ln>
         </p:spPr>
@@ -5634,8 +5579,8 @@
         </p:nvSpPr>
         <p:spPr>
           <a:xfrm>
-            <a:off x="530352" y="1600200"/>
-            <a:ext cx="5797296" cy="6629400"/>
+            <a:off x="502920" y="1572768"/>
+            <a:ext cx="5806440" cy="6355080"/>
           </a:xfrm>
           <a:prstGeom prst="rect">
             <a:avLst/>
@@ -5649,89 +5594,84 @@
           <a:lstStyle/>
           <a:p>
             <a:pPr algn="l">
+              <a:lnSpc>
+                <a:spcPct val="115000"/>
+              </a:lnSpc>
               <a:spcAft>
                 <a:spcPts val="1000"/>
               </a:spcAft>
             </a:pPr>
             <a:r>
-              <a:rPr sz="1800">
-                <a:solidFill>
-                  <a:srgbClr val="1D1D1D"/>
-                </a:solidFill>
-              </a:rPr>
-              <a:t>• Urea is a widely used nitrogen fertilizer in agriculture. It supports chlorophyll formation, leafy growth, and better crop productivity when applied at an appropriate dose.</a:t>
+              <a:rPr sz="1700">
+                <a:solidFill>
+                  <a:srgbClr val="1E1E1E"/>
+                </a:solidFill>
+              </a:rPr>
+              <a:t>• Urea is one of the most widely used nitrogen fertilizers because it contains a high percentage of nitrogen and is relatively affordable for farmers.</a:t>
             </a:r>
           </a:p>
           <a:p>
             <a:pPr algn="l">
+              <a:lnSpc>
+                <a:spcPct val="115000"/>
+              </a:lnSpc>
               <a:spcAft>
                 <a:spcPts val="1000"/>
               </a:spcAft>
             </a:pPr>
             <a:r>
-              <a:rPr sz="1800">
-                <a:solidFill>
-                  <a:srgbClr val="1D1D1D"/>
-                </a:solidFill>
-              </a:rPr>
-              <a:t>• This project explains both the beneficial effects and the risks of overusing urea in plant systems and soil environments.</a:t>
-            </a:r>
-          </a:p>
-        </p:txBody>
-      </p:sp>
-      <p:sp>
-        <p:nvSpPr>
-          <p:cNvPr id="5" name="Rectangle 4"/>
-          <p:cNvSpPr/>
-          <p:nvPr/>
-        </p:nvSpPr>
-        <p:spPr>
-          <a:xfrm>
-            <a:off x="530352" y="8732520"/>
-            <a:ext cx="5797296" cy="2697480"/>
+              <a:rPr sz="1700">
+                <a:solidFill>
+                  <a:srgbClr val="1E1E1E"/>
+                </a:solidFill>
+              </a:rPr>
+              <a:t>• Nitrogen is essential for chlorophyll formation, protein synthesis, and leaf development, so urea can significantly improve visible plant vigor when used properly.</a:t>
+            </a:r>
+          </a:p>
+          <a:p>
+            <a:pPr algn="l">
+              <a:lnSpc>
+                <a:spcPct val="115000"/>
+              </a:lnSpc>
+              <a:spcAft>
+                <a:spcPts val="1000"/>
+              </a:spcAft>
+            </a:pPr>
+            <a:r>
+              <a:rPr sz="1700">
+                <a:solidFill>
+                  <a:srgbClr val="1E1E1E"/>
+                </a:solidFill>
+              </a:rPr>
+              <a:t>• However, incorrect dosage or repeated overuse can disturb soil chemistry, reduce microbial health, and lower long-term crop sustainability.</a:t>
+            </a:r>
+          </a:p>
+        </p:txBody>
+      </p:sp>
+      <p:pic>
+        <p:nvPicPr>
+          <p:cNvPr id="5" name="Picture 4" descr="slide_02.png"/>
+          <p:cNvPicPr>
+            <a:picLocks noChangeAspect="1"/>
+          </p:cNvPicPr>
+          <p:nvPr/>
+        </p:nvPicPr>
+        <p:blipFill>
+          <a:blip r:embed="rId2"/>
+          <a:stretch>
+            <a:fillRect/>
+          </a:stretch>
+        </p:blipFill>
+        <p:spPr>
+          <a:xfrm>
+            <a:off x="502920" y="8183879"/>
+            <a:ext cx="5806440" cy="3063240"/>
           </a:xfrm>
           <a:prstGeom prst="rect">
             <a:avLst/>
           </a:prstGeom>
-          <a:solidFill>
-            <a:srgbClr val="F3F9F4"/>
-          </a:solidFill>
-          <a:ln w="22860">
-            <a:solidFill>
-              <a:srgbClr val="4E8C5B"/>
-            </a:solidFill>
-          </a:ln>
-        </p:spPr>
-        <p:style>
-          <a:lnRef idx="1">
-            <a:schemeClr val="accent1"/>
-          </a:lnRef>
-          <a:fillRef idx="3">
-            <a:schemeClr val="accent1"/>
-          </a:fillRef>
-          <a:effectRef idx="2">
-            <a:schemeClr val="accent1"/>
-          </a:effectRef>
-          <a:fontRef idx="minor">
-            <a:schemeClr val="lt1"/>
-          </a:fontRef>
-        </p:style>
-        <p:txBody>
-          <a:bodyPr rtlCol="0" anchor="ctr"/>
-          <a:lstStyle/>
-          <a:p>
-            <a:pPr algn="ctr"/>
-            <a:r>
-              <a:rPr b="1" sz="1600">
-                <a:solidFill>
-                  <a:srgbClr val="376D41"/>
-                </a:solidFill>
-              </a:rPr>
-              <a:t>Image Placeholder: Urea granules and seedlings</a:t>
-            </a:r>
-          </a:p>
-        </p:txBody>
-      </p:sp>
+        </p:spPr>
+      </p:pic>
     </p:spTree>
   </p:cSld>
   <p:clrMapOvr>
@@ -5765,9 +5705,9 @@
             <a:avLst/>
           </a:prstGeom>
           <a:noFill/>
-          <a:ln w="27940">
+          <a:ln w="31750">
             <a:solidFill>
-              <a:srgbClr val="1F5F3A"/>
+              <a:srgbClr val="1D5C38"/>
             </a:solidFill>
           </a:ln>
         </p:spPr>
@@ -5801,18 +5741,18 @@
         </p:nvSpPr>
         <p:spPr>
           <a:xfrm>
-            <a:off x="438912" y="411480"/>
-            <a:ext cx="5980176" cy="914400"/>
+            <a:off x="411480" y="384048"/>
+            <a:ext cx="6035040" cy="960120"/>
           </a:xfrm>
           <a:prstGeom prst="roundRect">
             <a:avLst/>
           </a:prstGeom>
           <a:solidFill>
-            <a:srgbClr val="397B47"/>
+            <a:srgbClr val="2A7E49"/>
           </a:solidFill>
           <a:ln>
             <a:solidFill>
-              <a:srgbClr val="397B47"/>
+              <a:srgbClr val="2A7E49"/>
             </a:solidFill>
           </a:ln>
         </p:spPr>
@@ -5854,8 +5794,8 @@
         </p:nvSpPr>
         <p:spPr>
           <a:xfrm>
-            <a:off x="530352" y="1600200"/>
-            <a:ext cx="5797296" cy="6629400"/>
+            <a:off x="502920" y="1572768"/>
+            <a:ext cx="5806440" cy="6355080"/>
           </a:xfrm>
           <a:prstGeom prst="rect">
             <a:avLst/>
@@ -5869,89 +5809,84 @@
           <a:lstStyle/>
           <a:p>
             <a:pPr algn="l">
+              <a:lnSpc>
+                <a:spcPct val="115000"/>
+              </a:lnSpc>
               <a:spcAft>
                 <a:spcPts val="1000"/>
               </a:spcAft>
             </a:pPr>
             <a:r>
-              <a:rPr sz="1800">
-                <a:solidFill>
-                  <a:srgbClr val="1D1D1D"/>
-                </a:solidFill>
-              </a:rPr>
-              <a:t>• Moderate urea treatment generally produced greener leaves and stronger growth than the control group.</a:t>
+              <a:rPr sz="1700">
+                <a:solidFill>
+                  <a:srgbClr val="1E1E1E"/>
+                </a:solidFill>
+              </a:rPr>
+              <a:t>• The moderate-dose urea group showed improved greenness, stronger stems, and faster height increase compared with the control group.</a:t>
             </a:r>
           </a:p>
           <a:p>
             <a:pPr algn="l">
+              <a:lnSpc>
+                <a:spcPct val="115000"/>
+              </a:lnSpc>
               <a:spcAft>
                 <a:spcPts val="1000"/>
               </a:spcAft>
             </a:pPr>
             <a:r>
-              <a:rPr sz="1800">
-                <a:solidFill>
-                  <a:srgbClr val="1D1D1D"/>
-                </a:solidFill>
-              </a:rPr>
-              <a:t>• High-dose treatment showed stress signs such as reduced vigor, yellowing, or leaf-edge damage.</a:t>
-            </a:r>
-          </a:p>
-        </p:txBody>
-      </p:sp>
-      <p:sp>
-        <p:nvSpPr>
-          <p:cNvPr id="5" name="Rectangle 4"/>
-          <p:cNvSpPr/>
-          <p:nvPr/>
-        </p:nvSpPr>
-        <p:spPr>
-          <a:xfrm>
-            <a:off x="530352" y="8732520"/>
-            <a:ext cx="5797296" cy="2697480"/>
+              <a:rPr sz="1700">
+                <a:solidFill>
+                  <a:srgbClr val="1E1E1E"/>
+                </a:solidFill>
+              </a:rPr>
+              <a:t>• The zero-urea group displayed slower vegetative growth, while excessive-dose groups developed stress signs and inconsistent development.</a:t>
+            </a:r>
+          </a:p>
+          <a:p>
+            <a:pPr algn="l">
+              <a:lnSpc>
+                <a:spcPct val="115000"/>
+              </a:lnSpc>
+              <a:spcAft>
+                <a:spcPts val="1000"/>
+              </a:spcAft>
+            </a:pPr>
+            <a:r>
+              <a:rPr sz="1700">
+                <a:solidFill>
+                  <a:srgbClr val="1E1E1E"/>
+                </a:solidFill>
+              </a:rPr>
+              <a:t>• These outcomes indicate that response quality depends strongly on concentration and management practice.</a:t>
+            </a:r>
+          </a:p>
+        </p:txBody>
+      </p:sp>
+      <p:pic>
+        <p:nvPicPr>
+          <p:cNvPr id="5" name="Picture 4" descr="slide_20.png"/>
+          <p:cNvPicPr>
+            <a:picLocks noChangeAspect="1"/>
+          </p:cNvPicPr>
+          <p:nvPr/>
+        </p:nvPicPr>
+        <p:blipFill>
+          <a:blip r:embed="rId2"/>
+          <a:stretch>
+            <a:fillRect/>
+          </a:stretch>
+        </p:blipFill>
+        <p:spPr>
+          <a:xfrm>
+            <a:off x="502920" y="8183879"/>
+            <a:ext cx="5806440" cy="3063240"/>
           </a:xfrm>
           <a:prstGeom prst="rect">
             <a:avLst/>
           </a:prstGeom>
-          <a:solidFill>
-            <a:srgbClr val="F3F9F4"/>
-          </a:solidFill>
-          <a:ln w="22860">
-            <a:solidFill>
-              <a:srgbClr val="4E8C5B"/>
-            </a:solidFill>
-          </a:ln>
-        </p:spPr>
-        <p:style>
-          <a:lnRef idx="1">
-            <a:schemeClr val="accent1"/>
-          </a:lnRef>
-          <a:fillRef idx="3">
-            <a:schemeClr val="accent1"/>
-          </a:fillRef>
-          <a:effectRef idx="2">
-            <a:schemeClr val="accent1"/>
-          </a:effectRef>
-          <a:fontRef idx="minor">
-            <a:schemeClr val="lt1"/>
-          </a:fontRef>
-        </p:style>
-        <p:txBody>
-          <a:bodyPr rtlCol="0" anchor="ctr"/>
-          <a:lstStyle/>
-          <a:p>
-            <a:pPr algn="ctr"/>
-            <a:r>
-              <a:rPr b="1" sz="1600">
-                <a:solidFill>
-                  <a:srgbClr val="376D41"/>
-                </a:solidFill>
-              </a:rPr>
-              <a:t>Image Placeholder: Observation table and pot photos</a:t>
-            </a:r>
-          </a:p>
-        </p:txBody>
-      </p:sp>
+        </p:spPr>
+      </p:pic>
     </p:spTree>
   </p:cSld>
   <p:clrMapOvr>
@@ -5985,9 +5920,9 @@
             <a:avLst/>
           </a:prstGeom>
           <a:noFill/>
-          <a:ln w="27940">
+          <a:ln w="31750">
             <a:solidFill>
-              <a:srgbClr val="1F5F3A"/>
+              <a:srgbClr val="1D5C38"/>
             </a:solidFill>
           </a:ln>
         </p:spPr>
@@ -6021,18 +5956,18 @@
         </p:nvSpPr>
         <p:spPr>
           <a:xfrm>
-            <a:off x="438912" y="411480"/>
-            <a:ext cx="5980176" cy="914400"/>
+            <a:off x="411480" y="384048"/>
+            <a:ext cx="6035040" cy="960120"/>
           </a:xfrm>
           <a:prstGeom prst="roundRect">
             <a:avLst/>
           </a:prstGeom>
           <a:solidFill>
-            <a:srgbClr val="397B47"/>
+            <a:srgbClr val="2A7E49"/>
           </a:solidFill>
           <a:ln>
             <a:solidFill>
-              <a:srgbClr val="397B47"/>
+              <a:srgbClr val="2A7E49"/>
             </a:solidFill>
           </a:ln>
         </p:spPr>
@@ -6074,8 +6009,8 @@
         </p:nvSpPr>
         <p:spPr>
           <a:xfrm>
-            <a:off x="530352" y="1600200"/>
-            <a:ext cx="5797296" cy="6629400"/>
+            <a:off x="502920" y="1572768"/>
+            <a:ext cx="5806440" cy="6355080"/>
           </a:xfrm>
           <a:prstGeom prst="rect">
             <a:avLst/>
@@ -6089,89 +6024,84 @@
           <a:lstStyle/>
           <a:p>
             <a:pPr algn="l">
+              <a:lnSpc>
+                <a:spcPct val="115000"/>
+              </a:lnSpc>
               <a:spcAft>
                 <a:spcPts val="1000"/>
               </a:spcAft>
             </a:pPr>
             <a:r>
-              <a:rPr sz="1800">
-                <a:solidFill>
-                  <a:srgbClr val="1D1D1D"/>
-                </a:solidFill>
-              </a:rPr>
-              <a:t>• Plant response to urea is dose-dependent: optimal levels are beneficial, while excess is harmful.</a:t>
+              <a:rPr sz="1700">
+                <a:solidFill>
+                  <a:srgbClr val="1E1E1E"/>
+                </a:solidFill>
+              </a:rPr>
+              <a:t>• Balanced urea use enhances plant growth by supplying nitrogen for chlorophyll production, protein synthesis, and tissue development.</a:t>
             </a:r>
           </a:p>
           <a:p>
             <a:pPr algn="l">
+              <a:lnSpc>
+                <a:spcPct val="115000"/>
+              </a:lnSpc>
               <a:spcAft>
                 <a:spcPts val="1000"/>
               </a:spcAft>
             </a:pPr>
             <a:r>
-              <a:rPr sz="1800">
-                <a:solidFill>
-                  <a:srgbClr val="1D1D1D"/>
-                </a:solidFill>
-              </a:rPr>
-              <a:t>• Therefore, precise dose management is essential for consistent and healthy plant development.</a:t>
-            </a:r>
-          </a:p>
-        </p:txBody>
-      </p:sp>
-      <p:sp>
-        <p:nvSpPr>
-          <p:cNvPr id="5" name="Rectangle 4"/>
-          <p:cNvSpPr/>
-          <p:nvPr/>
-        </p:nvSpPr>
-        <p:spPr>
-          <a:xfrm>
-            <a:off x="530352" y="8732520"/>
-            <a:ext cx="5797296" cy="2697480"/>
+              <a:rPr sz="1700">
+                <a:solidFill>
+                  <a:srgbClr val="1E1E1E"/>
+                </a:solidFill>
+              </a:rPr>
+              <a:t>• Both under-application and over-application can reduce overall growth efficiency and quality.</a:t>
+            </a:r>
+          </a:p>
+          <a:p>
+            <a:pPr algn="l">
+              <a:lnSpc>
+                <a:spcPct val="115000"/>
+              </a:lnSpc>
+              <a:spcAft>
+                <a:spcPts val="1000"/>
+              </a:spcAft>
+            </a:pPr>
+            <a:r>
+              <a:rPr sz="1700">
+                <a:solidFill>
+                  <a:srgbClr val="1E1E1E"/>
+                </a:solidFill>
+              </a:rPr>
+              <a:t>• Therefore, fertilizer planning should focus on optimum dose, timing, and soil condition rather than maximum quantity.</a:t>
+            </a:r>
+          </a:p>
+        </p:txBody>
+      </p:sp>
+      <p:pic>
+        <p:nvPicPr>
+          <p:cNvPr id="5" name="Picture 4" descr="slide_21.png"/>
+          <p:cNvPicPr>
+            <a:picLocks noChangeAspect="1"/>
+          </p:cNvPicPr>
+          <p:nvPr/>
+        </p:nvPicPr>
+        <p:blipFill>
+          <a:blip r:embed="rId2"/>
+          <a:stretch>
+            <a:fillRect/>
+          </a:stretch>
+        </p:blipFill>
+        <p:spPr>
+          <a:xfrm>
+            <a:off x="502920" y="8183879"/>
+            <a:ext cx="5806440" cy="3063240"/>
           </a:xfrm>
           <a:prstGeom prst="rect">
             <a:avLst/>
           </a:prstGeom>
-          <a:solidFill>
-            <a:srgbClr val="F3F9F4"/>
-          </a:solidFill>
-          <a:ln w="22860">
-            <a:solidFill>
-              <a:srgbClr val="4E8C5B"/>
-            </a:solidFill>
-          </a:ln>
-        </p:spPr>
-        <p:style>
-          <a:lnRef idx="1">
-            <a:schemeClr val="accent1"/>
-          </a:lnRef>
-          <a:fillRef idx="3">
-            <a:schemeClr val="accent1"/>
-          </a:fillRef>
-          <a:effectRef idx="2">
-            <a:schemeClr val="accent1"/>
-          </a:effectRef>
-          <a:fontRef idx="minor">
-            <a:schemeClr val="lt1"/>
-          </a:fontRef>
-        </p:style>
-        <p:txBody>
-          <a:bodyPr rtlCol="0" anchor="ctr"/>
-          <a:lstStyle/>
-          <a:p>
-            <a:pPr algn="ctr"/>
-            <a:r>
-              <a:rPr b="1" sz="1600">
-                <a:solidFill>
-                  <a:srgbClr val="376D41"/>
-                </a:solidFill>
-              </a:rPr>
-              <a:t>Image Placeholder: Growth response graph by dose</a:t>
-            </a:r>
-          </a:p>
-        </p:txBody>
-      </p:sp>
+        </p:spPr>
+      </p:pic>
     </p:spTree>
   </p:cSld>
   <p:clrMapOvr>
@@ -6205,9 +6135,9 @@
             <a:avLst/>
           </a:prstGeom>
           <a:noFill/>
-          <a:ln w="27940">
+          <a:ln w="31750">
             <a:solidFill>
-              <a:srgbClr val="1F5F3A"/>
+              <a:srgbClr val="1D5C38"/>
             </a:solidFill>
           </a:ln>
         </p:spPr>
@@ -6241,18 +6171,18 @@
         </p:nvSpPr>
         <p:spPr>
           <a:xfrm>
-            <a:off x="438912" y="411480"/>
-            <a:ext cx="5980176" cy="914400"/>
+            <a:off x="411480" y="384048"/>
+            <a:ext cx="6035040" cy="960120"/>
           </a:xfrm>
           <a:prstGeom prst="roundRect">
             <a:avLst/>
           </a:prstGeom>
           <a:solidFill>
-            <a:srgbClr val="397B47"/>
+            <a:srgbClr val="2A7E49"/>
           </a:solidFill>
           <a:ln>
             <a:solidFill>
-              <a:srgbClr val="397B47"/>
+              <a:srgbClr val="2A7E49"/>
             </a:solidFill>
           </a:ln>
         </p:spPr>
@@ -6294,8 +6224,8 @@
         </p:nvSpPr>
         <p:spPr>
           <a:xfrm>
-            <a:off x="530352" y="1600200"/>
-            <a:ext cx="5797296" cy="6629400"/>
+            <a:off x="502920" y="1572768"/>
+            <a:ext cx="5806440" cy="6355080"/>
           </a:xfrm>
           <a:prstGeom prst="rect">
             <a:avLst/>
@@ -6309,89 +6239,84 @@
           <a:lstStyle/>
           <a:p>
             <a:pPr algn="l">
+              <a:lnSpc>
+                <a:spcPct val="115000"/>
+              </a:lnSpc>
               <a:spcAft>
                 <a:spcPts val="1000"/>
               </a:spcAft>
             </a:pPr>
             <a:r>
-              <a:rPr sz="1800">
-                <a:solidFill>
-                  <a:srgbClr val="1D1D1D"/>
-                </a:solidFill>
-              </a:rPr>
-              <a:t>• Urea is an effective nitrogen source for improving plant growth when used responsibly.</a:t>
+              <a:rPr sz="1700">
+                <a:solidFill>
+                  <a:srgbClr val="1E1E1E"/>
+                </a:solidFill>
+              </a:rPr>
+              <a:t>• Urea is a useful and effective fertilizer when applied scientifically in the correct dose and at the proper growth stage.</a:t>
             </a:r>
           </a:p>
           <a:p>
             <a:pPr algn="l">
+              <a:lnSpc>
+                <a:spcPct val="115000"/>
+              </a:lnSpc>
               <a:spcAft>
                 <a:spcPts val="1000"/>
               </a:spcAft>
             </a:pPr>
             <a:r>
-              <a:rPr sz="1800">
-                <a:solidFill>
-                  <a:srgbClr val="1D1D1D"/>
-                </a:solidFill>
-              </a:rPr>
-              <a:t>• Sustainable practice requires balanced application to protect soil quality, plant health, and the environment.</a:t>
-            </a:r>
-          </a:p>
-        </p:txBody>
-      </p:sp>
-      <p:sp>
-        <p:nvSpPr>
-          <p:cNvPr id="5" name="Rectangle 4"/>
-          <p:cNvSpPr/>
-          <p:nvPr/>
-        </p:nvSpPr>
-        <p:spPr>
-          <a:xfrm>
-            <a:off x="530352" y="8732520"/>
-            <a:ext cx="5797296" cy="2697480"/>
+              <a:rPr sz="1700">
+                <a:solidFill>
+                  <a:srgbClr val="1E1E1E"/>
+                </a:solidFill>
+              </a:rPr>
+              <a:t>• The project confirms that optimum application improves plant performance, while excessive application can damage plants and ecosystems.</a:t>
+            </a:r>
+          </a:p>
+          <a:p>
+            <a:pPr algn="l">
+              <a:lnSpc>
+                <a:spcPct val="115000"/>
+              </a:lnSpc>
+              <a:spcAft>
+                <a:spcPts val="1000"/>
+              </a:spcAft>
+            </a:pPr>
+            <a:r>
+              <a:rPr sz="1700">
+                <a:solidFill>
+                  <a:srgbClr val="1E1E1E"/>
+                </a:solidFill>
+              </a:rPr>
+              <a:t>• Responsible fertilizer management is essential for healthy crops, sustainable farming, and long-term soil productivity.</a:t>
+            </a:r>
+          </a:p>
+        </p:txBody>
+      </p:sp>
+      <p:pic>
+        <p:nvPicPr>
+          <p:cNvPr id="5" name="Picture 4" descr="slide_22.png"/>
+          <p:cNvPicPr>
+            <a:picLocks noChangeAspect="1"/>
+          </p:cNvPicPr>
+          <p:nvPr/>
+        </p:nvPicPr>
+        <p:blipFill>
+          <a:blip r:embed="rId2"/>
+          <a:stretch>
+            <a:fillRect/>
+          </a:stretch>
+        </p:blipFill>
+        <p:spPr>
+          <a:xfrm>
+            <a:off x="502920" y="8183879"/>
+            <a:ext cx="5806440" cy="3063240"/>
           </a:xfrm>
           <a:prstGeom prst="rect">
             <a:avLst/>
           </a:prstGeom>
-          <a:solidFill>
-            <a:srgbClr val="F3F9F4"/>
-          </a:solidFill>
-          <a:ln w="22860">
-            <a:solidFill>
-              <a:srgbClr val="4E8C5B"/>
-            </a:solidFill>
-          </a:ln>
-        </p:spPr>
-        <p:style>
-          <a:lnRef idx="1">
-            <a:schemeClr val="accent1"/>
-          </a:lnRef>
-          <a:fillRef idx="3">
-            <a:schemeClr val="accent1"/>
-          </a:fillRef>
-          <a:effectRef idx="2">
-            <a:schemeClr val="accent1"/>
-          </a:effectRef>
-          <a:fontRef idx="minor">
-            <a:schemeClr val="lt1"/>
-          </a:fontRef>
-        </p:style>
-        <p:txBody>
-          <a:bodyPr rtlCol="0" anchor="ctr"/>
-          <a:lstStyle/>
-          <a:p>
-            <a:pPr algn="ctr"/>
-            <a:r>
-              <a:rPr b="1" sz="1600">
-                <a:solidFill>
-                  <a:srgbClr val="376D41"/>
-                </a:solidFill>
-              </a:rPr>
-              <a:t>Image Placeholder: Sustainable nutrient management</a:t>
-            </a:r>
-          </a:p>
-        </p:txBody>
-      </p:sp>
+        </p:spPr>
+      </p:pic>
     </p:spTree>
   </p:cSld>
   <p:clrMapOvr>
@@ -6425,9 +6350,9 @@
             <a:avLst/>
           </a:prstGeom>
           <a:noFill/>
-          <a:ln w="27940">
+          <a:ln w="31750">
             <a:solidFill>
-              <a:srgbClr val="1F5F3A"/>
+              <a:srgbClr val="1D5C38"/>
             </a:solidFill>
           </a:ln>
         </p:spPr>
@@ -6461,18 +6386,18 @@
         </p:nvSpPr>
         <p:spPr>
           <a:xfrm>
-            <a:off x="438912" y="411480"/>
-            <a:ext cx="5980176" cy="914400"/>
+            <a:off x="411480" y="384048"/>
+            <a:ext cx="6035040" cy="960120"/>
           </a:xfrm>
           <a:prstGeom prst="roundRect">
             <a:avLst/>
           </a:prstGeom>
           <a:solidFill>
-            <a:srgbClr val="397B47"/>
+            <a:srgbClr val="2A7E49"/>
           </a:solidFill>
           <a:ln>
             <a:solidFill>
-              <a:srgbClr val="397B47"/>
+              <a:srgbClr val="2A7E49"/>
             </a:solidFill>
           </a:ln>
         </p:spPr>
@@ -6514,8 +6439,8 @@
         </p:nvSpPr>
         <p:spPr>
           <a:xfrm>
-            <a:off x="530352" y="1600200"/>
-            <a:ext cx="5797296" cy="6629400"/>
+            <a:off x="502920" y="1572768"/>
+            <a:ext cx="5806440" cy="6355080"/>
           </a:xfrm>
           <a:prstGeom prst="rect">
             <a:avLst/>
@@ -6529,74 +6454,66 @@
           <a:lstStyle/>
           <a:p>
             <a:pPr algn="l">
+              <a:lnSpc>
+                <a:spcPct val="115000"/>
+              </a:lnSpc>
               <a:spcAft>
                 <a:spcPts val="1000"/>
               </a:spcAft>
             </a:pPr>
             <a:r>
-              <a:rPr sz="1800">
-                <a:solidFill>
-                  <a:srgbClr val="1D1D1D"/>
-                </a:solidFill>
-              </a:rPr>
-              <a:t>Thank you for your attention.</a:t>
-            </a:r>
-          </a:p>
-        </p:txBody>
-      </p:sp>
-      <p:sp>
-        <p:nvSpPr>
-          <p:cNvPr id="5" name="Rectangle 4"/>
-          <p:cNvSpPr/>
-          <p:nvPr/>
-        </p:nvSpPr>
-        <p:spPr>
-          <a:xfrm>
-            <a:off x="530352" y="8732520"/>
-            <a:ext cx="5797296" cy="2697480"/>
+              <a:rPr sz="1700">
+                <a:solidFill>
+                  <a:srgbClr val="1E1E1E"/>
+                </a:solidFill>
+              </a:rPr>
+              <a:t>• Thank you for reviewing this project on the effects of urea on plant growth.</a:t>
+            </a:r>
+          </a:p>
+          <a:p>
+            <a:pPr algn="l">
+              <a:lnSpc>
+                <a:spcPct val="115000"/>
+              </a:lnSpc>
+              <a:spcAft>
+                <a:spcPts val="1000"/>
+              </a:spcAft>
+            </a:pPr>
+            <a:r>
+              <a:rPr sz="1700">
+                <a:solidFill>
+                  <a:srgbClr val="1E1E1E"/>
+                </a:solidFill>
+              </a:rPr>
+              <a:t>• Questions and discussion are welcome.</a:t>
+            </a:r>
+          </a:p>
+        </p:txBody>
+      </p:sp>
+      <p:pic>
+        <p:nvPicPr>
+          <p:cNvPr id="5" name="Picture 4" descr="slide_23.png"/>
+          <p:cNvPicPr>
+            <a:picLocks noChangeAspect="1"/>
+          </p:cNvPicPr>
+          <p:nvPr/>
+        </p:nvPicPr>
+        <p:blipFill>
+          <a:blip r:embed="rId2"/>
+          <a:stretch>
+            <a:fillRect/>
+          </a:stretch>
+        </p:blipFill>
+        <p:spPr>
+          <a:xfrm>
+            <a:off x="502920" y="8183879"/>
+            <a:ext cx="5806440" cy="3063240"/>
           </a:xfrm>
           <a:prstGeom prst="rect">
             <a:avLst/>
           </a:prstGeom>
-          <a:solidFill>
-            <a:srgbClr val="F3F9F4"/>
-          </a:solidFill>
-          <a:ln w="22860">
-            <a:solidFill>
-              <a:srgbClr val="4E8C5B"/>
-            </a:solidFill>
-          </a:ln>
-        </p:spPr>
-        <p:style>
-          <a:lnRef idx="1">
-            <a:schemeClr val="accent1"/>
-          </a:lnRef>
-          <a:fillRef idx="3">
-            <a:schemeClr val="accent1"/>
-          </a:fillRef>
-          <a:effectRef idx="2">
-            <a:schemeClr val="accent1"/>
-          </a:effectRef>
-          <a:fontRef idx="minor">
-            <a:schemeClr val="lt1"/>
-          </a:fontRef>
-        </p:style>
-        <p:txBody>
-          <a:bodyPr rtlCol="0" anchor="ctr"/>
-          <a:lstStyle/>
-          <a:p>
-            <a:pPr algn="ctr"/>
-            <a:r>
-              <a:rPr b="1" sz="1600">
-                <a:solidFill>
-                  <a:srgbClr val="376D41"/>
-                </a:solidFill>
-              </a:rPr>
-              <a:t>Image Placeholder: Plant-themed thank you visual</a:t>
-            </a:r>
-          </a:p>
-        </p:txBody>
-      </p:sp>
+        </p:spPr>
+      </p:pic>
     </p:spTree>
   </p:cSld>
   <p:clrMapOvr>
@@ -6630,9 +6547,9 @@
             <a:avLst/>
           </a:prstGeom>
           <a:noFill/>
-          <a:ln w="27940">
+          <a:ln w="31750">
             <a:solidFill>
-              <a:srgbClr val="1F5F3A"/>
+              <a:srgbClr val="1D5C38"/>
             </a:solidFill>
           </a:ln>
         </p:spPr>
@@ -6666,18 +6583,18 @@
         </p:nvSpPr>
         <p:spPr>
           <a:xfrm>
-            <a:off x="438912" y="411480"/>
-            <a:ext cx="5980176" cy="914400"/>
+            <a:off x="411480" y="384048"/>
+            <a:ext cx="6035040" cy="960120"/>
           </a:xfrm>
           <a:prstGeom prst="roundRect">
             <a:avLst/>
           </a:prstGeom>
           <a:solidFill>
-            <a:srgbClr val="397B47"/>
+            <a:srgbClr val="2A7E49"/>
           </a:solidFill>
           <a:ln>
             <a:solidFill>
-              <a:srgbClr val="397B47"/>
+              <a:srgbClr val="2A7E49"/>
             </a:solidFill>
           </a:ln>
         </p:spPr>
@@ -6719,8 +6636,8 @@
         </p:nvSpPr>
         <p:spPr>
           <a:xfrm>
-            <a:off x="530352" y="1600200"/>
-            <a:ext cx="5797296" cy="6629400"/>
+            <a:off x="502920" y="1572768"/>
+            <a:ext cx="5806440" cy="6355080"/>
           </a:xfrm>
           <a:prstGeom prst="rect">
             <a:avLst/>
@@ -6734,89 +6651,84 @@
           <a:lstStyle/>
           <a:p>
             <a:pPr algn="l">
+              <a:lnSpc>
+                <a:spcPct val="115000"/>
+              </a:lnSpc>
               <a:spcAft>
                 <a:spcPts val="1000"/>
               </a:spcAft>
             </a:pPr>
             <a:r>
-              <a:rPr sz="1800">
-                <a:solidFill>
-                  <a:srgbClr val="1D1D1D"/>
-                </a:solidFill>
-              </a:rPr>
-              <a:t>• To study the effect of different quantities of urea on seed germination and plant growth.</a:t>
+              <a:rPr sz="1700">
+                <a:solidFill>
+                  <a:srgbClr val="1E1E1E"/>
+                </a:solidFill>
+              </a:rPr>
+              <a:t>• To evaluate how different concentrations of urea affect germination rate, plant height, leaf color, and overall seedling quality.</a:t>
             </a:r>
           </a:p>
           <a:p>
             <a:pPr algn="l">
+              <a:lnSpc>
+                <a:spcPct val="115000"/>
+              </a:lnSpc>
               <a:spcAft>
                 <a:spcPts val="1000"/>
               </a:spcAft>
             </a:pPr>
             <a:r>
-              <a:rPr sz="1800">
-                <a:solidFill>
-                  <a:srgbClr val="1D1D1D"/>
-                </a:solidFill>
-              </a:rPr>
-              <a:t>• To compare growth indicators such as height, number of leaves, and leaf color across treatment groups.</a:t>
-            </a:r>
-          </a:p>
-        </p:txBody>
-      </p:sp>
-      <p:sp>
-        <p:nvSpPr>
-          <p:cNvPr id="5" name="Rectangle 4"/>
-          <p:cNvSpPr/>
-          <p:nvPr/>
-        </p:nvSpPr>
-        <p:spPr>
-          <a:xfrm>
-            <a:off x="530352" y="8732520"/>
-            <a:ext cx="5797296" cy="2697480"/>
+              <a:rPr sz="1700">
+                <a:solidFill>
+                  <a:srgbClr val="1E1E1E"/>
+                </a:solidFill>
+              </a:rPr>
+              <a:t>• To identify a practical and safe application level that improves plant growth without causing fertilizer stress or nutrient imbalance.</a:t>
+            </a:r>
+          </a:p>
+          <a:p>
+            <a:pPr algn="l">
+              <a:lnSpc>
+                <a:spcPct val="115000"/>
+              </a:lnSpc>
+              <a:spcAft>
+                <a:spcPts val="1000"/>
+              </a:spcAft>
+            </a:pPr>
+            <a:r>
+              <a:rPr sz="1700">
+                <a:solidFill>
+                  <a:srgbClr val="1E1E1E"/>
+                </a:solidFill>
+              </a:rPr>
+              <a:t>• To build awareness about responsible fertilizer use in school-level agricultural science.</a:t>
+            </a:r>
+          </a:p>
+        </p:txBody>
+      </p:sp>
+      <p:pic>
+        <p:nvPicPr>
+          <p:cNvPr id="5" name="Picture 4" descr="slide_03.png"/>
+          <p:cNvPicPr>
+            <a:picLocks noChangeAspect="1"/>
+          </p:cNvPicPr>
+          <p:nvPr/>
+        </p:nvPicPr>
+        <p:blipFill>
+          <a:blip r:embed="rId2"/>
+          <a:stretch>
+            <a:fillRect/>
+          </a:stretch>
+        </p:blipFill>
+        <p:spPr>
+          <a:xfrm>
+            <a:off x="502920" y="8183879"/>
+            <a:ext cx="5806440" cy="3063240"/>
           </a:xfrm>
           <a:prstGeom prst="rect">
             <a:avLst/>
           </a:prstGeom>
-          <a:solidFill>
-            <a:srgbClr val="F3F9F4"/>
-          </a:solidFill>
-          <a:ln w="22860">
-            <a:solidFill>
-              <a:srgbClr val="4E8C5B"/>
-            </a:solidFill>
-          </a:ln>
-        </p:spPr>
-        <p:style>
-          <a:lnRef idx="1">
-            <a:schemeClr val="accent1"/>
-          </a:lnRef>
-          <a:fillRef idx="3">
-            <a:schemeClr val="accent1"/>
-          </a:fillRef>
-          <a:effectRef idx="2">
-            <a:schemeClr val="accent1"/>
-          </a:effectRef>
-          <a:fontRef idx="minor">
-            <a:schemeClr val="lt1"/>
-          </a:fontRef>
-        </p:style>
-        <p:txBody>
-          <a:bodyPr rtlCol="0" anchor="ctr"/>
-          <a:lstStyle/>
-          <a:p>
-            <a:pPr algn="ctr"/>
-            <a:r>
-              <a:rPr b="1" sz="1600">
-                <a:solidFill>
-                  <a:srgbClr val="376D41"/>
-                </a:solidFill>
-              </a:rPr>
-              <a:t>Image Placeholder: Labeled experimental pots</a:t>
-            </a:r>
-          </a:p>
-        </p:txBody>
-      </p:sp>
+        </p:spPr>
+      </p:pic>
     </p:spTree>
   </p:cSld>
   <p:clrMapOvr>
@@ -6850,9 +6762,9 @@
             <a:avLst/>
           </a:prstGeom>
           <a:noFill/>
-          <a:ln w="27940">
+          <a:ln w="31750">
             <a:solidFill>
-              <a:srgbClr val="1F5F3A"/>
+              <a:srgbClr val="1D5C38"/>
             </a:solidFill>
           </a:ln>
         </p:spPr>
@@ -6886,18 +6798,18 @@
         </p:nvSpPr>
         <p:spPr>
           <a:xfrm>
-            <a:off x="438912" y="411480"/>
-            <a:ext cx="5980176" cy="914400"/>
+            <a:off x="411480" y="384048"/>
+            <a:ext cx="6035040" cy="960120"/>
           </a:xfrm>
           <a:prstGeom prst="roundRect">
             <a:avLst/>
           </a:prstGeom>
           <a:solidFill>
-            <a:srgbClr val="397B47"/>
+            <a:srgbClr val="2A7E49"/>
           </a:solidFill>
           <a:ln>
             <a:solidFill>
-              <a:srgbClr val="397B47"/>
+              <a:srgbClr val="2A7E49"/>
             </a:solidFill>
           </a:ln>
         </p:spPr>
@@ -6939,8 +6851,8 @@
         </p:nvSpPr>
         <p:spPr>
           <a:xfrm>
-            <a:off x="530352" y="1600200"/>
-            <a:ext cx="5797296" cy="6629400"/>
+            <a:off x="502920" y="1572768"/>
+            <a:ext cx="5806440" cy="6355080"/>
           </a:xfrm>
           <a:prstGeom prst="rect">
             <a:avLst/>
@@ -6954,89 +6866,84 @@
           <a:lstStyle/>
           <a:p>
             <a:pPr algn="l">
+              <a:lnSpc>
+                <a:spcPct val="115000"/>
+              </a:lnSpc>
               <a:spcAft>
                 <a:spcPts val="1000"/>
               </a:spcAft>
             </a:pPr>
             <a:r>
-              <a:rPr sz="1800">
-                <a:solidFill>
-                  <a:srgbClr val="1D1D1D"/>
-                </a:solidFill>
-              </a:rPr>
-              <a:t>• Plants receiving an optimum amount of urea will grow faster and appear healthier due to improved nitrogen nutrition.</a:t>
+              <a:rPr sz="1700">
+                <a:solidFill>
+                  <a:srgbClr val="1E1E1E"/>
+                </a:solidFill>
+              </a:rPr>
+              <a:t>• If urea is applied in an optimum and measured amount, then plants will exhibit faster growth, greener leaves, and better biomass accumulation.</a:t>
             </a:r>
           </a:p>
           <a:p>
             <a:pPr algn="l">
+              <a:lnSpc>
+                <a:spcPct val="115000"/>
+              </a:lnSpc>
               <a:spcAft>
                 <a:spcPts val="1000"/>
               </a:spcAft>
             </a:pPr>
             <a:r>
-              <a:rPr sz="1800">
-                <a:solidFill>
-                  <a:srgbClr val="1D1D1D"/>
-                </a:solidFill>
-              </a:rPr>
-              <a:t>• Plants exposed to excessive urea may show stress symptoms such as leaf burn, weak roots, and reduced growth.</a:t>
-            </a:r>
-          </a:p>
-        </p:txBody>
-      </p:sp>
-      <p:sp>
-        <p:nvSpPr>
-          <p:cNvPr id="5" name="Rectangle 4"/>
-          <p:cNvSpPr/>
-          <p:nvPr/>
-        </p:nvSpPr>
-        <p:spPr>
-          <a:xfrm>
-            <a:off x="530352" y="8732520"/>
-            <a:ext cx="5797296" cy="2697480"/>
+              <a:rPr sz="1700">
+                <a:solidFill>
+                  <a:srgbClr val="1E1E1E"/>
+                </a:solidFill>
+              </a:rPr>
+              <a:t>• If urea is applied above the tolerance limit, then plants may show growth suppression, root injury, or leaf-tip burn due to osmotic and chemical stress.</a:t>
+            </a:r>
+          </a:p>
+          <a:p>
+            <a:pPr algn="l">
+              <a:lnSpc>
+                <a:spcPct val="115000"/>
+              </a:lnSpc>
+              <a:spcAft>
+                <a:spcPts val="1000"/>
+              </a:spcAft>
+            </a:pPr>
+            <a:r>
+              <a:rPr sz="1700">
+                <a:solidFill>
+                  <a:srgbClr val="1E1E1E"/>
+                </a:solidFill>
+              </a:rPr>
+              <a:t>• Therefore, plant response is expected to be dose-dependent rather than simply increasing with more fertilizer.</a:t>
+            </a:r>
+          </a:p>
+        </p:txBody>
+      </p:sp>
+      <p:pic>
+        <p:nvPicPr>
+          <p:cNvPr id="5" name="Picture 4" descr="slide_04.png"/>
+          <p:cNvPicPr>
+            <a:picLocks noChangeAspect="1"/>
+          </p:cNvPicPr>
+          <p:nvPr/>
+        </p:nvPicPr>
+        <p:blipFill>
+          <a:blip r:embed="rId2"/>
+          <a:stretch>
+            <a:fillRect/>
+          </a:stretch>
+        </p:blipFill>
+        <p:spPr>
+          <a:xfrm>
+            <a:off x="502920" y="8183879"/>
+            <a:ext cx="5806440" cy="3063240"/>
           </a:xfrm>
           <a:prstGeom prst="rect">
             <a:avLst/>
           </a:prstGeom>
-          <a:solidFill>
-            <a:srgbClr val="F3F9F4"/>
-          </a:solidFill>
-          <a:ln w="22860">
-            <a:solidFill>
-              <a:srgbClr val="4E8C5B"/>
-            </a:solidFill>
-          </a:ln>
-        </p:spPr>
-        <p:style>
-          <a:lnRef idx="1">
-            <a:schemeClr val="accent1"/>
-          </a:lnRef>
-          <a:fillRef idx="3">
-            <a:schemeClr val="accent1"/>
-          </a:fillRef>
-          <a:effectRef idx="2">
-            <a:schemeClr val="accent1"/>
-          </a:effectRef>
-          <a:fontRef idx="minor">
-            <a:schemeClr val="lt1"/>
-          </a:fontRef>
-        </p:style>
-        <p:txBody>
-          <a:bodyPr rtlCol="0" anchor="ctr"/>
-          <a:lstStyle/>
-          <a:p>
-            <a:pPr algn="ctr"/>
-            <a:r>
-              <a:rPr b="1" sz="1600">
-                <a:solidFill>
-                  <a:srgbClr val="376D41"/>
-                </a:solidFill>
-              </a:rPr>
-              <a:t>Image Placeholder: Correct dose vs excessive dose comparison</a:t>
-            </a:r>
-          </a:p>
-        </p:txBody>
-      </p:sp>
+        </p:spPr>
+      </p:pic>
     </p:spTree>
   </p:cSld>
   <p:clrMapOvr>
@@ -7070,9 +6977,9 @@
             <a:avLst/>
           </a:prstGeom>
           <a:noFill/>
-          <a:ln w="27940">
+          <a:ln w="31750">
             <a:solidFill>
-              <a:srgbClr val="1F5F3A"/>
+              <a:srgbClr val="1D5C38"/>
             </a:solidFill>
           </a:ln>
         </p:spPr>
@@ -7106,18 +7013,18 @@
         </p:nvSpPr>
         <p:spPr>
           <a:xfrm>
-            <a:off x="438912" y="411480"/>
-            <a:ext cx="5980176" cy="914400"/>
+            <a:off x="411480" y="384048"/>
+            <a:ext cx="6035040" cy="960120"/>
           </a:xfrm>
           <a:prstGeom prst="roundRect">
             <a:avLst/>
           </a:prstGeom>
           <a:solidFill>
-            <a:srgbClr val="397B47"/>
+            <a:srgbClr val="2A7E49"/>
           </a:solidFill>
           <a:ln>
             <a:solidFill>
-              <a:srgbClr val="397B47"/>
+              <a:srgbClr val="2A7E49"/>
             </a:solidFill>
           </a:ln>
         </p:spPr>
@@ -7159,8 +7066,8 @@
         </p:nvSpPr>
         <p:spPr>
           <a:xfrm>
-            <a:off x="530352" y="1600200"/>
-            <a:ext cx="5797296" cy="6629400"/>
+            <a:off x="502920" y="1572768"/>
+            <a:ext cx="5806440" cy="6355080"/>
           </a:xfrm>
           <a:prstGeom prst="rect">
             <a:avLst/>
@@ -7174,89 +7081,84 @@
           <a:lstStyle/>
           <a:p>
             <a:pPr algn="l">
+              <a:lnSpc>
+                <a:spcPct val="115000"/>
+              </a:lnSpc>
               <a:spcAft>
                 <a:spcPts val="1000"/>
               </a:spcAft>
             </a:pPr>
             <a:r>
-              <a:rPr sz="1800">
-                <a:solidFill>
-                  <a:srgbClr val="1D1D1D"/>
-                </a:solidFill>
-              </a:rPr>
-              <a:t>• Germination is the process by which a seed develops into a seedling after absorbing water and activating its metabolism.</a:t>
+              <a:rPr sz="1700">
+                <a:solidFill>
+                  <a:srgbClr val="1E1E1E"/>
+                </a:solidFill>
+              </a:rPr>
+              <a:t>• Germination starts when a dry seed absorbs water and activates enzymes that convert stored food into usable energy for the embryo.</a:t>
             </a:r>
           </a:p>
           <a:p>
             <a:pPr algn="l">
+              <a:lnSpc>
+                <a:spcPct val="115000"/>
+              </a:lnSpc>
               <a:spcAft>
                 <a:spcPts val="1000"/>
               </a:spcAft>
             </a:pPr>
             <a:r>
-              <a:rPr sz="1800">
-                <a:solidFill>
-                  <a:srgbClr val="1D1D1D"/>
-                </a:solidFill>
-              </a:rPr>
-              <a:t>• Successful germination requires a viable embryo and favorable environmental conditions.</a:t>
-            </a:r>
-          </a:p>
-        </p:txBody>
-      </p:sp>
-      <p:sp>
-        <p:nvSpPr>
-          <p:cNvPr id="5" name="Rectangle 4"/>
-          <p:cNvSpPr/>
-          <p:nvPr/>
-        </p:nvSpPr>
-        <p:spPr>
-          <a:xfrm>
-            <a:off x="530352" y="8732520"/>
-            <a:ext cx="5797296" cy="2697480"/>
+              <a:rPr sz="1700">
+                <a:solidFill>
+                  <a:srgbClr val="1E1E1E"/>
+                </a:solidFill>
+              </a:rPr>
+              <a:t>• The radicle emerges first to form the root system, followed by shoot emergence that establishes early seedling growth.</a:t>
+            </a:r>
+          </a:p>
+          <a:p>
+            <a:pPr algn="l">
+              <a:lnSpc>
+                <a:spcPct val="115000"/>
+              </a:lnSpc>
+              <a:spcAft>
+                <a:spcPts val="1000"/>
+              </a:spcAft>
+            </a:pPr>
+            <a:r>
+              <a:rPr sz="1700">
+                <a:solidFill>
+                  <a:srgbClr val="1E1E1E"/>
+                </a:solidFill>
+              </a:rPr>
+              <a:t>• Uniform germination is a key indicator of seed quality and favorable environmental conditions.</a:t>
+            </a:r>
+          </a:p>
+        </p:txBody>
+      </p:sp>
+      <p:pic>
+        <p:nvPicPr>
+          <p:cNvPr id="5" name="Picture 4" descr="slide_05.png"/>
+          <p:cNvPicPr>
+            <a:picLocks noChangeAspect="1"/>
+          </p:cNvPicPr>
+          <p:nvPr/>
+        </p:nvPicPr>
+        <p:blipFill>
+          <a:blip r:embed="rId2"/>
+          <a:stretch>
+            <a:fillRect/>
+          </a:stretch>
+        </p:blipFill>
+        <p:spPr>
+          <a:xfrm>
+            <a:off x="502920" y="8183879"/>
+            <a:ext cx="5806440" cy="3063240"/>
           </a:xfrm>
           <a:prstGeom prst="rect">
             <a:avLst/>
           </a:prstGeom>
-          <a:solidFill>
-            <a:srgbClr val="F3F9F4"/>
-          </a:solidFill>
-          <a:ln w="22860">
-            <a:solidFill>
-              <a:srgbClr val="4E8C5B"/>
-            </a:solidFill>
-          </a:ln>
-        </p:spPr>
-        <p:style>
-          <a:lnRef idx="1">
-            <a:schemeClr val="accent1"/>
-          </a:lnRef>
-          <a:fillRef idx="3">
-            <a:schemeClr val="accent1"/>
-          </a:fillRef>
-          <a:effectRef idx="2">
-            <a:schemeClr val="accent1"/>
-          </a:effectRef>
-          <a:fontRef idx="minor">
-            <a:schemeClr val="lt1"/>
-          </a:fontRef>
-        </p:style>
-        <p:txBody>
-          <a:bodyPr rtlCol="0" anchor="ctr"/>
-          <a:lstStyle/>
-          <a:p>
-            <a:pPr algn="ctr"/>
-            <a:r>
-              <a:rPr b="1" sz="1600">
-                <a:solidFill>
-                  <a:srgbClr val="376D41"/>
-                </a:solidFill>
-              </a:rPr>
-              <a:t>Image Placeholder: Stages of seed germination</a:t>
-            </a:r>
-          </a:p>
-        </p:txBody>
-      </p:sp>
+        </p:spPr>
+      </p:pic>
     </p:spTree>
   </p:cSld>
   <p:clrMapOvr>
@@ -7290,9 +7192,9 @@
             <a:avLst/>
           </a:prstGeom>
           <a:noFill/>
-          <a:ln w="27940">
+          <a:ln w="31750">
             <a:solidFill>
-              <a:srgbClr val="1F5F3A"/>
+              <a:srgbClr val="1D5C38"/>
             </a:solidFill>
           </a:ln>
         </p:spPr>
@@ -7326,18 +7228,18 @@
         </p:nvSpPr>
         <p:spPr>
           <a:xfrm>
-            <a:off x="438912" y="411480"/>
-            <a:ext cx="5980176" cy="914400"/>
+            <a:off x="411480" y="384048"/>
+            <a:ext cx="6035040" cy="960120"/>
           </a:xfrm>
           <a:prstGeom prst="roundRect">
             <a:avLst/>
           </a:prstGeom>
           <a:solidFill>
-            <a:srgbClr val="397B47"/>
+            <a:srgbClr val="2A7E49"/>
           </a:solidFill>
           <a:ln>
             <a:solidFill>
-              <a:srgbClr val="397B47"/>
+              <a:srgbClr val="2A7E49"/>
             </a:solidFill>
           </a:ln>
         </p:spPr>
@@ -7379,8 +7281,8 @@
         </p:nvSpPr>
         <p:spPr>
           <a:xfrm>
-            <a:off x="530352" y="1600200"/>
-            <a:ext cx="5797296" cy="6629400"/>
+            <a:off x="502920" y="1572768"/>
+            <a:ext cx="5806440" cy="6355080"/>
           </a:xfrm>
           <a:prstGeom prst="rect">
             <a:avLst/>
@@ -7394,89 +7296,84 @@
           <a:lstStyle/>
           <a:p>
             <a:pPr algn="l">
+              <a:lnSpc>
+                <a:spcPct val="115000"/>
+              </a:lnSpc>
               <a:spcAft>
                 <a:spcPts val="1000"/>
               </a:spcAft>
             </a:pPr>
             <a:r>
-              <a:rPr sz="1800">
-                <a:solidFill>
-                  <a:srgbClr val="1D1D1D"/>
-                </a:solidFill>
-              </a:rPr>
-              <a:t>• Seed germination is influenced by external factors such as water, oxygen, temperature, and light.</a:t>
+              <a:rPr sz="1700">
+                <a:solidFill>
+                  <a:srgbClr val="1E1E1E"/>
+                </a:solidFill>
+              </a:rPr>
+              <a:t>• Seed germination depends on both external environmental factors and internal biological conditions of the seed.</a:t>
             </a:r>
           </a:p>
           <a:p>
             <a:pPr algn="l">
+              <a:lnSpc>
+                <a:spcPct val="115000"/>
+              </a:lnSpc>
               <a:spcAft>
                 <a:spcPts val="1000"/>
               </a:spcAft>
             </a:pPr>
             <a:r>
-              <a:rPr sz="1800">
-                <a:solidFill>
-                  <a:srgbClr val="1D1D1D"/>
-                </a:solidFill>
-              </a:rPr>
-              <a:t>• It is also affected by internal factors like vitality, viability, and dormancy status.</a:t>
-            </a:r>
-          </a:p>
-        </p:txBody>
-      </p:sp>
-      <p:sp>
-        <p:nvSpPr>
-          <p:cNvPr id="5" name="Rectangle 4"/>
-          <p:cNvSpPr/>
-          <p:nvPr/>
-        </p:nvSpPr>
-        <p:spPr>
-          <a:xfrm>
-            <a:off x="530352" y="8732520"/>
-            <a:ext cx="5797296" cy="2697480"/>
+              <a:rPr sz="1700">
+                <a:solidFill>
+                  <a:srgbClr val="1E1E1E"/>
+                </a:solidFill>
+              </a:rPr>
+              <a:t>• External factors include water, oxygen, temperature, and light, while internal factors include vitality, viability, and dormancy.</a:t>
+            </a:r>
+          </a:p>
+          <a:p>
+            <a:pPr algn="l">
+              <a:lnSpc>
+                <a:spcPct val="115000"/>
+              </a:lnSpc>
+              <a:spcAft>
+                <a:spcPts val="1000"/>
+              </a:spcAft>
+            </a:pPr>
+            <a:r>
+              <a:rPr sz="1700">
+                <a:solidFill>
+                  <a:srgbClr val="1E1E1E"/>
+                </a:solidFill>
+              </a:rPr>
+              <a:t>• A deficiency in any essential factor can delay or prevent successful seed establishment.</a:t>
+            </a:r>
+          </a:p>
+        </p:txBody>
+      </p:sp>
+      <p:pic>
+        <p:nvPicPr>
+          <p:cNvPr id="5" name="Picture 4" descr="slide_06.png"/>
+          <p:cNvPicPr>
+            <a:picLocks noChangeAspect="1"/>
+          </p:cNvPicPr>
+          <p:nvPr/>
+        </p:nvPicPr>
+        <p:blipFill>
+          <a:blip r:embed="rId2"/>
+          <a:stretch>
+            <a:fillRect/>
+          </a:stretch>
+        </p:blipFill>
+        <p:spPr>
+          <a:xfrm>
+            <a:off x="502920" y="8183879"/>
+            <a:ext cx="5806440" cy="3063240"/>
           </a:xfrm>
           <a:prstGeom prst="rect">
             <a:avLst/>
           </a:prstGeom>
-          <a:solidFill>
-            <a:srgbClr val="F3F9F4"/>
-          </a:solidFill>
-          <a:ln w="22860">
-            <a:solidFill>
-              <a:srgbClr val="4E8C5B"/>
-            </a:solidFill>
-          </a:ln>
-        </p:spPr>
-        <p:style>
-          <a:lnRef idx="1">
-            <a:schemeClr val="accent1"/>
-          </a:lnRef>
-          <a:fillRef idx="3">
-            <a:schemeClr val="accent1"/>
-          </a:fillRef>
-          <a:effectRef idx="2">
-            <a:schemeClr val="accent1"/>
-          </a:effectRef>
-          <a:fontRef idx="minor">
-            <a:schemeClr val="lt1"/>
-          </a:fontRef>
-        </p:style>
-        <p:txBody>
-          <a:bodyPr rtlCol="0" anchor="ctr"/>
-          <a:lstStyle/>
-          <a:p>
-            <a:pPr algn="ctr"/>
-            <a:r>
-              <a:rPr b="1" sz="1600">
-                <a:solidFill>
-                  <a:srgbClr val="376D41"/>
-                </a:solidFill>
-              </a:rPr>
-              <a:t>Image Placeholder: External and internal factor chart</a:t>
-            </a:r>
-          </a:p>
-        </p:txBody>
-      </p:sp>
+        </p:spPr>
+      </p:pic>
     </p:spTree>
   </p:cSld>
   <p:clrMapOvr>
@@ -7510,9 +7407,9 @@
             <a:avLst/>
           </a:prstGeom>
           <a:noFill/>
-          <a:ln w="27940">
+          <a:ln w="31750">
             <a:solidFill>
-              <a:srgbClr val="1F5F3A"/>
+              <a:srgbClr val="1D5C38"/>
             </a:solidFill>
           </a:ln>
         </p:spPr>
@@ -7546,18 +7443,18 @@
         </p:nvSpPr>
         <p:spPr>
           <a:xfrm>
-            <a:off x="438912" y="411480"/>
-            <a:ext cx="5980176" cy="914400"/>
+            <a:off x="411480" y="384048"/>
+            <a:ext cx="6035040" cy="960120"/>
           </a:xfrm>
           <a:prstGeom prst="roundRect">
             <a:avLst/>
           </a:prstGeom>
           <a:solidFill>
-            <a:srgbClr val="397B47"/>
+            <a:srgbClr val="2A7E49"/>
           </a:solidFill>
           <a:ln>
             <a:solidFill>
-              <a:srgbClr val="397B47"/>
+              <a:srgbClr val="2A7E49"/>
             </a:solidFill>
           </a:ln>
         </p:spPr>
@@ -7599,8 +7496,8 @@
         </p:nvSpPr>
         <p:spPr>
           <a:xfrm>
-            <a:off x="530352" y="1600200"/>
-            <a:ext cx="5797296" cy="6629400"/>
+            <a:off x="502920" y="1572768"/>
+            <a:ext cx="5806440" cy="6355080"/>
           </a:xfrm>
           <a:prstGeom prst="rect">
             <a:avLst/>
@@ -7614,89 +7511,84 @@
           <a:lstStyle/>
           <a:p>
             <a:pPr algn="l">
+              <a:lnSpc>
+                <a:spcPct val="115000"/>
+              </a:lnSpc>
               <a:spcAft>
                 <a:spcPts val="1000"/>
               </a:spcAft>
             </a:pPr>
             <a:r>
-              <a:rPr sz="1800">
-                <a:solidFill>
-                  <a:srgbClr val="1D1D1D"/>
-                </a:solidFill>
-              </a:rPr>
-              <a:t>• External conditions surrounding the seed directly control when and how fast germination occurs.</a:t>
+              <a:rPr sz="1700">
+                <a:solidFill>
+                  <a:srgbClr val="1E1E1E"/>
+                </a:solidFill>
+              </a:rPr>
+              <a:t>• External factors are the surrounding physical conditions that directly control germination speed and seedling success.</a:t>
             </a:r>
           </a:p>
           <a:p>
             <a:pPr algn="l">
+              <a:lnSpc>
+                <a:spcPct val="115000"/>
+              </a:lnSpc>
               <a:spcAft>
                 <a:spcPts val="1000"/>
               </a:spcAft>
             </a:pPr>
             <a:r>
-              <a:rPr sz="1800">
-                <a:solidFill>
-                  <a:srgbClr val="1D1D1D"/>
-                </a:solidFill>
-              </a:rPr>
-              <a:t>• Major external factors include water, oxygen, temperature, light, and soil condition.</a:t>
-            </a:r>
-          </a:p>
-        </p:txBody>
-      </p:sp>
-      <p:sp>
-        <p:nvSpPr>
-          <p:cNvPr id="5" name="Rectangle 4"/>
-          <p:cNvSpPr/>
-          <p:nvPr/>
-        </p:nvSpPr>
-        <p:spPr>
-          <a:xfrm>
-            <a:off x="530352" y="8732520"/>
-            <a:ext cx="5797296" cy="2697480"/>
+              <a:rPr sz="1700">
+                <a:solidFill>
+                  <a:srgbClr val="1E1E1E"/>
+                </a:solidFill>
+              </a:rPr>
+              <a:t>• Water enables metabolic activation, oxygen supports respiration, temperature regulates enzyme activity, and light affects specific seed types.</a:t>
+            </a:r>
+          </a:p>
+          <a:p>
+            <a:pPr algn="l">
+              <a:lnSpc>
+                <a:spcPct val="115000"/>
+              </a:lnSpc>
+              <a:spcAft>
+                <a:spcPts val="1000"/>
+              </a:spcAft>
+            </a:pPr>
+            <a:r>
+              <a:rPr sz="1700">
+                <a:solidFill>
+                  <a:srgbClr val="1E1E1E"/>
+                </a:solidFill>
+              </a:rPr>
+              <a:t>• Soil texture, pH, and moisture-holding capacity also influence germination outcomes in real field conditions.</a:t>
+            </a:r>
+          </a:p>
+        </p:txBody>
+      </p:sp>
+      <p:pic>
+        <p:nvPicPr>
+          <p:cNvPr id="5" name="Picture 4" descr="slide_07.png"/>
+          <p:cNvPicPr>
+            <a:picLocks noChangeAspect="1"/>
+          </p:cNvPicPr>
+          <p:nvPr/>
+        </p:nvPicPr>
+        <p:blipFill>
+          <a:blip r:embed="rId2"/>
+          <a:stretch>
+            <a:fillRect/>
+          </a:stretch>
+        </p:blipFill>
+        <p:spPr>
+          <a:xfrm>
+            <a:off x="502920" y="8183879"/>
+            <a:ext cx="5806440" cy="3063240"/>
           </a:xfrm>
           <a:prstGeom prst="rect">
             <a:avLst/>
           </a:prstGeom>
-          <a:solidFill>
-            <a:srgbClr val="F3F9F4"/>
-          </a:solidFill>
-          <a:ln w="22860">
-            <a:solidFill>
-              <a:srgbClr val="4E8C5B"/>
-            </a:solidFill>
-          </a:ln>
-        </p:spPr>
-        <p:style>
-          <a:lnRef idx="1">
-            <a:schemeClr val="accent1"/>
-          </a:lnRef>
-          <a:fillRef idx="3">
-            <a:schemeClr val="accent1"/>
-          </a:fillRef>
-          <a:effectRef idx="2">
-            <a:schemeClr val="accent1"/>
-          </a:effectRef>
-          <a:fontRef idx="minor">
-            <a:schemeClr val="lt1"/>
-          </a:fontRef>
-        </p:style>
-        <p:txBody>
-          <a:bodyPr rtlCol="0" anchor="ctr"/>
-          <a:lstStyle/>
-          <a:p>
-            <a:pPr algn="ctr"/>
-            <a:r>
-              <a:rPr b="1" sz="1600">
-                <a:solidFill>
-                  <a:srgbClr val="376D41"/>
-                </a:solidFill>
-              </a:rPr>
-              <a:t>Image Placeholder: Environmental condition icons</a:t>
-            </a:r>
-          </a:p>
-        </p:txBody>
-      </p:sp>
+        </p:spPr>
+      </p:pic>
     </p:spTree>
   </p:cSld>
   <p:clrMapOvr>
@@ -7730,9 +7622,9 @@
             <a:avLst/>
           </a:prstGeom>
           <a:noFill/>
-          <a:ln w="27940">
+          <a:ln w="31750">
             <a:solidFill>
-              <a:srgbClr val="1F5F3A"/>
+              <a:srgbClr val="1D5C38"/>
             </a:solidFill>
           </a:ln>
         </p:spPr>
@@ -7766,18 +7658,18 @@
         </p:nvSpPr>
         <p:spPr>
           <a:xfrm>
-            <a:off x="438912" y="411480"/>
-            <a:ext cx="5980176" cy="914400"/>
+            <a:off x="411480" y="384048"/>
+            <a:ext cx="6035040" cy="960120"/>
           </a:xfrm>
           <a:prstGeom prst="roundRect">
             <a:avLst/>
           </a:prstGeom>
           <a:solidFill>
-            <a:srgbClr val="397B47"/>
+            <a:srgbClr val="2A7E49"/>
           </a:solidFill>
           <a:ln>
             <a:solidFill>
-              <a:srgbClr val="397B47"/>
+              <a:srgbClr val="2A7E49"/>
             </a:solidFill>
           </a:ln>
         </p:spPr>
@@ -7819,8 +7711,8 @@
         </p:nvSpPr>
         <p:spPr>
           <a:xfrm>
-            <a:off x="530352" y="1600200"/>
-            <a:ext cx="5797296" cy="6629400"/>
+            <a:off x="502920" y="1572768"/>
+            <a:ext cx="5806440" cy="6355080"/>
           </a:xfrm>
           <a:prstGeom prst="rect">
             <a:avLst/>
@@ -7834,89 +7726,84 @@
           <a:lstStyle/>
           <a:p>
             <a:pPr algn="l">
+              <a:lnSpc>
+                <a:spcPct val="115000"/>
+              </a:lnSpc>
               <a:spcAft>
                 <a:spcPts val="1000"/>
               </a:spcAft>
             </a:pPr>
             <a:r>
-              <a:rPr sz="1800">
-                <a:solidFill>
-                  <a:srgbClr val="1D1D1D"/>
-                </a:solidFill>
-              </a:rPr>
-              <a:t>• Water softens the seed coat, activates enzymes, and supports the movement of stored food to the embryo.</a:t>
+              <a:rPr sz="1700">
+                <a:solidFill>
+                  <a:srgbClr val="1E1E1E"/>
+                </a:solidFill>
+              </a:rPr>
+              <a:t>• Water is required for imbibition, enzyme activation, and the transport of nutrients to developing tissues in the embryo.</a:t>
             </a:r>
           </a:p>
           <a:p>
             <a:pPr algn="l">
+              <a:lnSpc>
+                <a:spcPct val="115000"/>
+              </a:lnSpc>
               <a:spcAft>
                 <a:spcPts val="1000"/>
               </a:spcAft>
             </a:pPr>
             <a:r>
-              <a:rPr sz="1800">
-                <a:solidFill>
-                  <a:srgbClr val="1D1D1D"/>
-                </a:solidFill>
-              </a:rPr>
-              <a:t>• Too little water delays germination, while excess water can reduce oxygen availability.</a:t>
-            </a:r>
-          </a:p>
-        </p:txBody>
-      </p:sp>
-      <p:sp>
-        <p:nvSpPr>
-          <p:cNvPr id="5" name="Rectangle 4"/>
-          <p:cNvSpPr/>
-          <p:nvPr/>
-        </p:nvSpPr>
-        <p:spPr>
-          <a:xfrm>
-            <a:off x="530352" y="8732520"/>
-            <a:ext cx="5797296" cy="2697480"/>
+              <a:rPr sz="1700">
+                <a:solidFill>
+                  <a:srgbClr val="1E1E1E"/>
+                </a:solidFill>
+              </a:rPr>
+              <a:t>• Insufficient moisture causes delayed germination, while excessive water can create anaerobic conditions that reduce oxygen availability.</a:t>
+            </a:r>
+          </a:p>
+          <a:p>
+            <a:pPr algn="l">
+              <a:lnSpc>
+                <a:spcPct val="115000"/>
+              </a:lnSpc>
+              <a:spcAft>
+                <a:spcPts val="1000"/>
+              </a:spcAft>
+            </a:pPr>
+            <a:r>
+              <a:rPr sz="1700">
+                <a:solidFill>
+                  <a:srgbClr val="1E1E1E"/>
+                </a:solidFill>
+              </a:rPr>
+              <a:t>• Balanced and regular watering is essential for uniform sprouting and early root establishment.</a:t>
+            </a:r>
+          </a:p>
+        </p:txBody>
+      </p:sp>
+      <p:pic>
+        <p:nvPicPr>
+          <p:cNvPr id="5" name="Picture 4" descr="slide_08.png"/>
+          <p:cNvPicPr>
+            <a:picLocks noChangeAspect="1"/>
+          </p:cNvPicPr>
+          <p:nvPr/>
+        </p:nvPicPr>
+        <p:blipFill>
+          <a:blip r:embed="rId2"/>
+          <a:stretch>
+            <a:fillRect/>
+          </a:stretch>
+        </p:blipFill>
+        <p:spPr>
+          <a:xfrm>
+            <a:off x="502920" y="8183879"/>
+            <a:ext cx="5806440" cy="3063240"/>
           </a:xfrm>
           <a:prstGeom prst="rect">
             <a:avLst/>
           </a:prstGeom>
-          <a:solidFill>
-            <a:srgbClr val="F3F9F4"/>
-          </a:solidFill>
-          <a:ln w="22860">
-            <a:solidFill>
-              <a:srgbClr val="4E8C5B"/>
-            </a:solidFill>
-          </a:ln>
-        </p:spPr>
-        <p:style>
-          <a:lnRef idx="1">
-            <a:schemeClr val="accent1"/>
-          </a:lnRef>
-          <a:fillRef idx="3">
-            <a:schemeClr val="accent1"/>
-          </a:fillRef>
-          <a:effectRef idx="2">
-            <a:schemeClr val="accent1"/>
-          </a:effectRef>
-          <a:fontRef idx="minor">
-            <a:schemeClr val="lt1"/>
-          </a:fontRef>
-        </p:style>
-        <p:txBody>
-          <a:bodyPr rtlCol="0" anchor="ctr"/>
-          <a:lstStyle/>
-          <a:p>
-            <a:pPr algn="ctr"/>
-            <a:r>
-              <a:rPr b="1" sz="1600">
-                <a:solidFill>
-                  <a:srgbClr val="376D41"/>
-                </a:solidFill>
-              </a:rPr>
-              <a:t>Image Placeholder: Watering seed trays</a:t>
-            </a:r>
-          </a:p>
-        </p:txBody>
-      </p:sp>
+        </p:spPr>
+      </p:pic>
     </p:spTree>
   </p:cSld>
   <p:clrMapOvr>
@@ -7950,9 +7837,9 @@
             <a:avLst/>
           </a:prstGeom>
           <a:noFill/>
-          <a:ln w="27940">
+          <a:ln w="31750">
             <a:solidFill>
-              <a:srgbClr val="1F5F3A"/>
+              <a:srgbClr val="1D5C38"/>
             </a:solidFill>
           </a:ln>
         </p:spPr>
@@ -7986,18 +7873,18 @@
         </p:nvSpPr>
         <p:spPr>
           <a:xfrm>
-            <a:off x="438912" y="411480"/>
-            <a:ext cx="5980176" cy="914400"/>
+            <a:off x="411480" y="384048"/>
+            <a:ext cx="6035040" cy="960120"/>
           </a:xfrm>
           <a:prstGeom prst="roundRect">
             <a:avLst/>
           </a:prstGeom>
           <a:solidFill>
-            <a:srgbClr val="397B47"/>
+            <a:srgbClr val="2A7E49"/>
           </a:solidFill>
           <a:ln>
             <a:solidFill>
-              <a:srgbClr val="397B47"/>
+              <a:srgbClr val="2A7E49"/>
             </a:solidFill>
           </a:ln>
         </p:spPr>
@@ -8039,8 +7926,8 @@
         </p:nvSpPr>
         <p:spPr>
           <a:xfrm>
-            <a:off x="530352" y="1600200"/>
-            <a:ext cx="5797296" cy="6629400"/>
+            <a:off x="502920" y="1572768"/>
+            <a:ext cx="5806440" cy="6355080"/>
           </a:xfrm>
           <a:prstGeom prst="rect">
             <a:avLst/>
@@ -8054,89 +7941,84 @@
           <a:lstStyle/>
           <a:p>
             <a:pPr algn="l">
+              <a:lnSpc>
+                <a:spcPct val="115000"/>
+              </a:lnSpc>
               <a:spcAft>
                 <a:spcPts val="1000"/>
               </a:spcAft>
             </a:pPr>
             <a:r>
-              <a:rPr sz="1800">
-                <a:solidFill>
-                  <a:srgbClr val="1D1D1D"/>
-                </a:solidFill>
-              </a:rPr>
-              <a:t>• Seeds need oxygen for respiration, which produces energy for growth and cell division.</a:t>
+              <a:rPr sz="1700">
+                <a:solidFill>
+                  <a:srgbClr val="1E1E1E"/>
+                </a:solidFill>
+              </a:rPr>
+              <a:t>• Germinating seeds use oxygen for aerobic respiration to generate ATP, the energy currency needed for growth and cell division.</a:t>
             </a:r>
           </a:p>
           <a:p>
             <a:pPr algn="l">
+              <a:lnSpc>
+                <a:spcPct val="115000"/>
+              </a:lnSpc>
               <a:spcAft>
                 <a:spcPts val="1000"/>
               </a:spcAft>
             </a:pPr>
             <a:r>
-              <a:rPr sz="1800">
-                <a:solidFill>
-                  <a:srgbClr val="1D1D1D"/>
-                </a:solidFill>
-              </a:rPr>
-              <a:t>• Compacted or waterlogged soil lowers oxygen supply and can decrease germination percentage.</a:t>
-            </a:r>
-          </a:p>
-        </p:txBody>
-      </p:sp>
-      <p:sp>
-        <p:nvSpPr>
-          <p:cNvPr id="5" name="Rectangle 4"/>
-          <p:cNvSpPr/>
-          <p:nvPr/>
-        </p:nvSpPr>
-        <p:spPr>
-          <a:xfrm>
-            <a:off x="530352" y="8732520"/>
-            <a:ext cx="5797296" cy="2697480"/>
+              <a:rPr sz="1700">
+                <a:solidFill>
+                  <a:srgbClr val="1E1E1E"/>
+                </a:solidFill>
+              </a:rPr>
+              <a:t>• When soil is compacted or waterlogged, oxygen diffusion decreases and germination percentage may drop significantly.</a:t>
+            </a:r>
+          </a:p>
+          <a:p>
+            <a:pPr algn="l">
+              <a:lnSpc>
+                <a:spcPct val="115000"/>
+              </a:lnSpc>
+              <a:spcAft>
+                <a:spcPts val="1000"/>
+              </a:spcAft>
+            </a:pPr>
+            <a:r>
+              <a:rPr sz="1700">
+                <a:solidFill>
+                  <a:srgbClr val="1E1E1E"/>
+                </a:solidFill>
+              </a:rPr>
+              <a:t>• Adequate aeration around seeds helps maintain healthy root emergence and strong seedlings.</a:t>
+            </a:r>
+          </a:p>
+        </p:txBody>
+      </p:sp>
+      <p:pic>
+        <p:nvPicPr>
+          <p:cNvPr id="5" name="Picture 4" descr="slide_09.png"/>
+          <p:cNvPicPr>
+            <a:picLocks noChangeAspect="1"/>
+          </p:cNvPicPr>
+          <p:nvPr/>
+        </p:nvPicPr>
+        <p:blipFill>
+          <a:blip r:embed="rId2"/>
+          <a:stretch>
+            <a:fillRect/>
+          </a:stretch>
+        </p:blipFill>
+        <p:spPr>
+          <a:xfrm>
+            <a:off x="502920" y="8183879"/>
+            <a:ext cx="5806440" cy="3063240"/>
           </a:xfrm>
           <a:prstGeom prst="rect">
             <a:avLst/>
           </a:prstGeom>
-          <a:solidFill>
-            <a:srgbClr val="F3F9F4"/>
-          </a:solidFill>
-          <a:ln w="22860">
-            <a:solidFill>
-              <a:srgbClr val="4E8C5B"/>
-            </a:solidFill>
-          </a:ln>
-        </p:spPr>
-        <p:style>
-          <a:lnRef idx="1">
-            <a:schemeClr val="accent1"/>
-          </a:lnRef>
-          <a:fillRef idx="3">
-            <a:schemeClr val="accent1"/>
-          </a:fillRef>
-          <a:effectRef idx="2">
-            <a:schemeClr val="accent1"/>
-          </a:effectRef>
-          <a:fontRef idx="minor">
-            <a:schemeClr val="lt1"/>
-          </a:fontRef>
-        </p:style>
-        <p:txBody>
-          <a:bodyPr rtlCol="0" anchor="ctr"/>
-          <a:lstStyle/>
-          <a:p>
-            <a:pPr algn="ctr"/>
-            <a:r>
-              <a:rPr b="1" sz="1600">
-                <a:solidFill>
-                  <a:srgbClr val="376D41"/>
-                </a:solidFill>
-              </a:rPr>
-              <a:t>Image Placeholder: Seed respiration in soil</a:t>
-            </a:r>
-          </a:p>
-        </p:txBody>
-      </p:sp>
+        </p:spPr>
+      </p:pic>
     </p:spTree>
   </p:cSld>
   <p:clrMapOvr>

</xml_diff>